<commit_message>
Add two design-kit slides to the campaign deck
Slides 10-11 showcase the produced assets as thumbnails: pre-launch and
launch-day pieces, then sales/Spaces/weekly templates, each labeled with
its calendar slot. Notes which video work remains with the editor.

Co-Authored-By: Claude Fable 5 <noreply@anthropic.com>
Claude-Session: https://claude.ai/code/session_01HeCjF7fsjCUn5ySBJ1uikn
</commit_message>
<xml_diff>
--- a/marketing/Rally_Permissionless_Campaigns_Plan.pptx
+++ b/marketing/Rally_Permissionless_Campaigns_Plan.pptx
@@ -15,9 +15,11 @@
     <p:sldId id="263" r:id="rId9"/>
     <p:sldId id="264" r:id="rId10"/>
     <p:sldId id="265" r:id="rId11"/>
+    <p:sldId id="266" r:id="rId12"/>
+    <p:sldId id="267" r:id="rId13"/>
   </p:sldIdLst>
   <p:notesMasterIdLst>
-    <p:notesMasterId r:id="rId12"/>
+    <p:notesMasterId r:id="rId14"/>
   </p:notesMasterIdLst>
   <p:sldSz cx="12192000" cy="6858000"/>
   <p:notesSz cx="6858000" cy="12192000"/>
@@ -623,6 +625,182 @@
             <a:fld id="{F7021451-1387-4CA6-816F-3879F97B5CBC}" type="slidenum">
               <a:rPr lang="en-US"/>
               <a:t>10</a:t>
+            </a:fld>
+            <a:endParaRPr lang="en-US"/>
+          </a:p>
+        </p:txBody>
+      </p:sp>
+    </p:spTree>
+    <p:extLst>
+      <p:ext uri="{BB962C8B-B14F-4D97-AF65-F5344CB8AC3E}">
+        <p14:creationId xmlns:p14="http://schemas.microsoft.com/office/powerpoint/2010/main" val="1024086991"/>
+      </p:ext>
+    </p:extLst>
+  </p:cSld>
+  <p:clrMapOvr>
+    <a:masterClrMapping/>
+  </p:clrMapOvr>
+</p:notes>
+</file>
+
+<file path=ppt/notesSlides/notesSlide11.xml><?xml version="1.0" encoding="utf-8"?>
+<p:notes xmlns:a="http://schemas.openxmlformats.org/drawingml/2006/main" xmlns:r="http://schemas.openxmlformats.org/officeDocument/2006/relationships" xmlns:p="http://schemas.openxmlformats.org/presentationml/2006/main">
+  <p:cSld>
+    <p:spTree>
+      <p:nvGrpSpPr>
+        <p:cNvPr id="1" name=""/>
+        <p:cNvGrpSpPr/>
+        <p:nvPr/>
+      </p:nvGrpSpPr>
+      <p:grpSpPr>
+        <a:xfrm>
+          <a:off x="0" y="0"/>
+          <a:ext cx="0" cy="0"/>
+          <a:chOff x="0" y="0"/>
+          <a:chExt cx="0" cy="0"/>
+        </a:xfrm>
+      </p:grpSpPr>
+      <p:sp>
+        <p:nvSpPr>
+          <p:cNvPr id="2" name="Slide Image Placeholder 1"/>
+          <p:cNvSpPr>
+            <a:spLocks noGrp="1" noRot="1" noChangeAspect="1"/>
+          </p:cNvSpPr>
+          <p:nvPr>
+            <p:ph type="sldImg"/>
+          </p:nvPr>
+        </p:nvSpPr>
+        <p:spPr/>
+      </p:sp>
+      <p:sp>
+        <p:nvSpPr>
+          <p:cNvPr id="3" name="Notes Placeholder 2"/>
+          <p:cNvSpPr>
+            <a:spLocks noGrp="1"/>
+          </p:cNvSpPr>
+          <p:nvPr>
+            <p:ph type="body" idx="1"/>
+          </p:nvPr>
+        </p:nvSpPr>
+        <p:spPr/>
+        <p:txBody>
+          <a:bodyPr/>
+          <a:lstStyle/>
+          <a:p>
+            <a:r>
+              <a:rPr lang="en-US" dirty="0"/>
+              <a:t/>
+            </a:r>
+            <a:endParaRPr lang="en-US" dirty="0"/>
+          </a:p>
+        </p:txBody>
+      </p:sp>
+      <p:sp>
+        <p:nvSpPr>
+          <p:cNvPr id="4" name="Slide Number Placeholder 3"/>
+          <p:cNvSpPr>
+            <a:spLocks noGrp="1"/>
+          </p:cNvSpPr>
+          <p:nvPr>
+            <p:ph type="sldNum" sz="quarter" idx="10"/>
+          </p:nvPr>
+        </p:nvSpPr>
+        <p:spPr/>
+        <p:txBody>
+          <a:bodyPr/>
+          <a:lstStyle/>
+          <a:p>
+            <a:fld id="{F7021451-1387-4CA6-816F-3879F97B5CBC}" type="slidenum">
+              <a:rPr lang="en-US"/>
+              <a:t>11</a:t>
+            </a:fld>
+            <a:endParaRPr lang="en-US"/>
+          </a:p>
+        </p:txBody>
+      </p:sp>
+    </p:spTree>
+    <p:extLst>
+      <p:ext uri="{BB962C8B-B14F-4D97-AF65-F5344CB8AC3E}">
+        <p14:creationId xmlns:p14="http://schemas.microsoft.com/office/powerpoint/2010/main" val="1024086991"/>
+      </p:ext>
+    </p:extLst>
+  </p:cSld>
+  <p:clrMapOvr>
+    <a:masterClrMapping/>
+  </p:clrMapOvr>
+</p:notes>
+</file>
+
+<file path=ppt/notesSlides/notesSlide12.xml><?xml version="1.0" encoding="utf-8"?>
+<p:notes xmlns:a="http://schemas.openxmlformats.org/drawingml/2006/main" xmlns:r="http://schemas.openxmlformats.org/officeDocument/2006/relationships" xmlns:p="http://schemas.openxmlformats.org/presentationml/2006/main">
+  <p:cSld>
+    <p:spTree>
+      <p:nvGrpSpPr>
+        <p:cNvPr id="1" name=""/>
+        <p:cNvGrpSpPr/>
+        <p:nvPr/>
+      </p:nvGrpSpPr>
+      <p:grpSpPr>
+        <a:xfrm>
+          <a:off x="0" y="0"/>
+          <a:ext cx="0" cy="0"/>
+          <a:chOff x="0" y="0"/>
+          <a:chExt cx="0" cy="0"/>
+        </a:xfrm>
+      </p:grpSpPr>
+      <p:sp>
+        <p:nvSpPr>
+          <p:cNvPr id="2" name="Slide Image Placeholder 1"/>
+          <p:cNvSpPr>
+            <a:spLocks noGrp="1" noRot="1" noChangeAspect="1"/>
+          </p:cNvSpPr>
+          <p:nvPr>
+            <p:ph type="sldImg"/>
+          </p:nvPr>
+        </p:nvSpPr>
+        <p:spPr/>
+      </p:sp>
+      <p:sp>
+        <p:nvSpPr>
+          <p:cNvPr id="3" name="Notes Placeholder 2"/>
+          <p:cNvSpPr>
+            <a:spLocks noGrp="1"/>
+          </p:cNvSpPr>
+          <p:nvPr>
+            <p:ph type="body" idx="1"/>
+          </p:nvPr>
+        </p:nvSpPr>
+        <p:spPr/>
+        <p:txBody>
+          <a:bodyPr/>
+          <a:lstStyle/>
+          <a:p>
+            <a:r>
+              <a:rPr lang="en-US" dirty="0"/>
+              <a:t/>
+            </a:r>
+            <a:endParaRPr lang="en-US" dirty="0"/>
+          </a:p>
+        </p:txBody>
+      </p:sp>
+      <p:sp>
+        <p:nvSpPr>
+          <p:cNvPr id="4" name="Slide Number Placeholder 3"/>
+          <p:cNvSpPr>
+            <a:spLocks noGrp="1"/>
+          </p:cNvSpPr>
+          <p:nvPr>
+            <p:ph type="sldNum" sz="quarter" idx="10"/>
+          </p:nvPr>
+        </p:nvSpPr>
+        <p:spPr/>
+        <p:txBody>
+          <a:bodyPr/>
+          <a:lstStyle/>
+          <a:p>
+            <a:fld id="{F7021451-1387-4CA6-816F-3879F97B5CBC}" type="slidenum">
+              <a:rPr lang="en-US"/>
+              <a:t>12</a:t>
             </a:fld>
             <a:endParaRPr lang="en-US"/>
           </a:p>
@@ -2032,6 +2210,1753 @@
           <a:chExt cx="0" cy="0"/>
         </a:xfrm>
       </p:grpSpPr>
+      <p:sp>
+        <p:nvSpPr>
+          <p:cNvPr id="2" name="Text 0"/>
+          <p:cNvSpPr/>
+          <p:nvPr/>
+        </p:nvSpPr>
+        <p:spPr>
+          <a:xfrm>
+            <a:off x="502920" y="347472"/>
+            <a:ext cx="8961120" cy="274320"/>
+          </a:xfrm>
+          <a:prstGeom prst="rect">
+            <a:avLst/>
+          </a:prstGeom>
+          <a:noFill/>
+          <a:ln/>
+        </p:spPr>
+        <p:txBody>
+          <a:bodyPr wrap="square" lIns="0" tIns="0" rIns="0" bIns="0" rtlCol="0" anchor="ctr"/>
+          <a:lstStyle/>
+          <a:p>
+            <a:pPr indent="0" marL="0">
+              <a:buNone/>
+            </a:pPr>
+            <a:r>
+              <a:rPr lang="en-US" sz="1150" b="1" spc="300" kern="0" dirty="0">
+                <a:solidFill>
+                  <a:srgbClr val="FF4E00"/>
+                </a:solidFill>
+                <a:latin typeface="Calibri" pitchFamily="34" charset="0"/>
+                <a:ea typeface="Calibri" pitchFamily="34" charset="-122"/>
+                <a:cs typeface="Calibri" pitchFamily="34" charset="-120"/>
+              </a:rPr>
+              <a:t>DESIGN KIT · ALREADY PRODUCED</a:t>
+            </a:r>
+            <a:endParaRPr lang="en-US" sz="1150" dirty="0"/>
+          </a:p>
+        </p:txBody>
+      </p:sp>
+      <p:sp>
+        <p:nvSpPr>
+          <p:cNvPr id="3" name="Text 1"/>
+          <p:cNvSpPr/>
+          <p:nvPr/>
+        </p:nvSpPr>
+        <p:spPr>
+          <a:xfrm>
+            <a:off x="502920" y="621792"/>
+            <a:ext cx="11155680" cy="548640"/>
+          </a:xfrm>
+          <a:prstGeom prst="rect">
+            <a:avLst/>
+          </a:prstGeom>
+          <a:noFill/>
+          <a:ln/>
+        </p:spPr>
+        <p:txBody>
+          <a:bodyPr wrap="square" lIns="0" tIns="0" rIns="0" bIns="0" rtlCol="0" anchor="ctr"/>
+          <a:lstStyle/>
+          <a:p>
+            <a:pPr indent="0" marL="0">
+              <a:buNone/>
+            </a:pPr>
+            <a:r>
+              <a:rPr lang="en-US" sz="2700" b="1" dirty="0">
+                <a:solidFill>
+                  <a:srgbClr val="2A1A38"/>
+                </a:solidFill>
+                <a:latin typeface="Calibri" pitchFamily="34" charset="0"/>
+                <a:ea typeface="Calibri" pitchFamily="34" charset="-122"/>
+                <a:cs typeface="Calibri" pitchFamily="34" charset="-120"/>
+              </a:rPr>
+              <a:t>Pre-launch &amp; launch day — ready to post</a:t>
+            </a:r>
+            <a:endParaRPr lang="en-US" sz="2700" dirty="0"/>
+          </a:p>
+        </p:txBody>
+      </p:sp>
+      <p:sp>
+        <p:nvSpPr>
+          <p:cNvPr id="4" name="Shape 2"/>
+          <p:cNvSpPr/>
+          <p:nvPr/>
+        </p:nvSpPr>
+        <p:spPr>
+          <a:xfrm>
+            <a:off x="9646920" y="365760"/>
+            <a:ext cx="2084832" cy="329184"/>
+          </a:xfrm>
+          <a:prstGeom prst="roundRect">
+            <a:avLst>
+              <a:gd name="adj" fmla="val 38889"/>
+            </a:avLst>
+          </a:prstGeom>
+          <a:solidFill>
+            <a:srgbClr val="FF4E00"/>
+          </a:solidFill>
+          <a:ln/>
+        </p:spPr>
+      </p:sp>
+      <p:sp>
+        <p:nvSpPr>
+          <p:cNvPr id="5" name="Text 3">
+            <a:hlinkClick r:id="rId1" tooltip="Design kit"/>
+          </p:cNvPr>
+          <p:cNvSpPr/>
+          <p:nvPr/>
+        </p:nvSpPr>
+        <p:spPr>
+          <a:xfrm>
+            <a:off x="9646920" y="365760"/>
+            <a:ext cx="2084832" cy="329184"/>
+          </a:xfrm>
+          <a:prstGeom prst="rect">
+            <a:avLst/>
+          </a:prstGeom>
+          <a:noFill/>
+          <a:ln/>
+        </p:spPr>
+        <p:txBody>
+          <a:bodyPr wrap="square" lIns="0" tIns="0" rIns="0" bIns="0" rtlCol="0" anchor="ctr"/>
+          <a:lstStyle/>
+          <a:p>
+            <a:pPr algn="ctr" indent="0" marL="0">
+              <a:buNone/>
+            </a:pPr>
+            <a:r>
+              <a:rPr lang="en-US" sz="1050" b="1" u="sng" dirty="0">
+                <a:solidFill>
+                  <a:srgbClr val="25043A"/>
+                </a:solidFill>
+                <a:latin typeface="Calibri" pitchFamily="34" charset="0"/>
+                <a:ea typeface="Calibri" pitchFamily="34" charset="-122"/>
+                <a:cs typeface="Calibri" pitchFamily="34" charset="-120"/>
+                <a:hlinkClick r:id="rId1" invalidUrl="" action="" tgtFrame="" tooltip="Design kit" history="1" highlightClick="0" endSnd="0">
+                  <a:extLst>
+                    <a:ext uri="{A12FA001-AC4F-418D-AE19-62706E023703}">
+                      <ahyp:hlinkClr xmlns:ahyp="http://schemas.microsoft.com/office/drawing/2018/hyperlinkcolor" val="tx"/>
+                    </a:ext>
+                  </a:extLst>
+                </a:hlinkClick>
+              </a:rPr>
+              <a:t>MASTER DOC  ▸</a:t>
+            </a:r>
+            <a:endParaRPr lang="en-US" sz="1050" dirty="0"/>
+          </a:p>
+        </p:txBody>
+      </p:sp>
+      <p:sp>
+        <p:nvSpPr>
+          <p:cNvPr id="6" name="Shape 4"/>
+          <p:cNvSpPr/>
+          <p:nvPr/>
+        </p:nvSpPr>
+        <p:spPr>
+          <a:xfrm>
+            <a:off x="466344" y="1563624"/>
+            <a:ext cx="3685032" cy="2103120"/>
+          </a:xfrm>
+          <a:prstGeom prst="roundRect">
+            <a:avLst>
+              <a:gd name="adj" fmla="val 2609"/>
+            </a:avLst>
+          </a:prstGeom>
+          <a:solidFill>
+            <a:srgbClr val="F8F1EC"/>
+          </a:solidFill>
+          <a:ln/>
+        </p:spPr>
+      </p:sp>
+      <p:pic>
+        <p:nvPicPr>
+          <p:cNvPr id="7" name="Image 0" descr="/tmp/claude-0/-home-user-predictionmarket/cadac25f-7355-5a2e-945b-6583f4b657ab/scratchpad/deck/designs/teaser_coming_1600x900.png">    </p:cNvPr>
+          <p:cNvPicPr>
+            <a:picLocks noChangeAspect="1"/>
+          </p:cNvPicPr>
+          <p:nvPr/>
+        </p:nvPicPr>
+        <p:blipFill>
+          <a:blip r:embed="rId2"/>
+          <a:stretch>
+            <a:fillRect/>
+          </a:stretch>
+        </p:blipFill>
+        <p:spPr>
+          <a:xfrm>
+            <a:off x="502920" y="1600200"/>
+            <a:ext cx="3611880" cy="2029968"/>
+          </a:xfrm>
+          <a:prstGeom prst="rect">
+            <a:avLst/>
+          </a:prstGeom>
+        </p:spPr>
+      </p:pic>
+      <p:sp>
+        <p:nvSpPr>
+          <p:cNvPr id="8" name="Text 5"/>
+          <p:cNvSpPr/>
+          <p:nvPr/>
+        </p:nvSpPr>
+        <p:spPr>
+          <a:xfrm>
+            <a:off x="502920" y="3675888"/>
+            <a:ext cx="3611880" cy="219456"/>
+          </a:xfrm>
+          <a:prstGeom prst="rect">
+            <a:avLst/>
+          </a:prstGeom>
+          <a:noFill/>
+          <a:ln/>
+        </p:spPr>
+        <p:txBody>
+          <a:bodyPr wrap="square" lIns="0" tIns="0" rIns="0" bIns="0" rtlCol="0" anchor="ctr"/>
+          <a:lstStyle/>
+          <a:p>
+            <a:pPr indent="0" marL="0">
+              <a:buNone/>
+            </a:pPr>
+            <a:r>
+              <a:rPr lang="en-US" sz="900" b="1" dirty="0">
+                <a:solidFill>
+                  <a:srgbClr val="6B6273"/>
+                </a:solidFill>
+                <a:latin typeface="Calibri" pitchFamily="34" charset="0"/>
+                <a:ea typeface="Calibri" pitchFamily="34" charset="-122"/>
+                <a:cs typeface="Calibri" pitchFamily="34" charset="-120"/>
+              </a:rPr>
+              <a:t>TEASER · THU 13</a:t>
+            </a:r>
+            <a:endParaRPr lang="en-US" sz="900" dirty="0"/>
+          </a:p>
+        </p:txBody>
+      </p:sp>
+      <p:sp>
+        <p:nvSpPr>
+          <p:cNvPr id="9" name="Shape 6"/>
+          <p:cNvSpPr/>
+          <p:nvPr/>
+        </p:nvSpPr>
+        <p:spPr>
+          <a:xfrm>
+            <a:off x="4261104" y="1563624"/>
+            <a:ext cx="3685032" cy="2103120"/>
+          </a:xfrm>
+          <a:prstGeom prst="roundRect">
+            <a:avLst>
+              <a:gd name="adj" fmla="val 2609"/>
+            </a:avLst>
+          </a:prstGeom>
+          <a:solidFill>
+            <a:srgbClr val="F8F1EC"/>
+          </a:solidFill>
+          <a:ln/>
+        </p:spPr>
+      </p:sp>
+      <p:pic>
+        <p:nvPicPr>
+          <p:cNvPr id="10" name="Image 1" descr="/tmp/claude-0/-home-user-predictionmarket/cadac25f-7355-5a2e-945b-6583f4b657ab/scratchpad/deck/designs/countdown_rally_3days_1600x900.png">    </p:cNvPr>
+          <p:cNvPicPr>
+            <a:picLocks noChangeAspect="1"/>
+          </p:cNvPicPr>
+          <p:nvPr/>
+        </p:nvPicPr>
+        <p:blipFill>
+          <a:blip r:embed="rId3"/>
+          <a:stretch>
+            <a:fillRect/>
+          </a:stretch>
+        </p:blipFill>
+        <p:spPr>
+          <a:xfrm>
+            <a:off x="4297680" y="1600200"/>
+            <a:ext cx="3611880" cy="2029968"/>
+          </a:xfrm>
+          <a:prstGeom prst="rect">
+            <a:avLst/>
+          </a:prstGeom>
+        </p:spPr>
+      </p:pic>
+      <p:sp>
+        <p:nvSpPr>
+          <p:cNvPr id="11" name="Text 7"/>
+          <p:cNvSpPr/>
+          <p:nvPr/>
+        </p:nvSpPr>
+        <p:spPr>
+          <a:xfrm>
+            <a:off x="4297680" y="3675888"/>
+            <a:ext cx="3611880" cy="219456"/>
+          </a:xfrm>
+          <a:prstGeom prst="rect">
+            <a:avLst/>
+          </a:prstGeom>
+          <a:noFill/>
+          <a:ln/>
+        </p:spPr>
+        <p:txBody>
+          <a:bodyPr wrap="square" lIns="0" tIns="0" rIns="0" bIns="0" rtlCol="0" anchor="ctr"/>
+          <a:lstStyle/>
+          <a:p>
+            <a:pPr indent="0" marL="0">
+              <a:buNone/>
+            </a:pPr>
+            <a:r>
+              <a:rPr lang="en-US" sz="900" b="1" dirty="0">
+                <a:solidFill>
+                  <a:srgbClr val="6B6273"/>
+                </a:solidFill>
+                <a:latin typeface="Calibri" pitchFamily="34" charset="0"/>
+                <a:ea typeface="Calibri" pitchFamily="34" charset="-122"/>
+                <a:cs typeface="Calibri" pitchFamily="34" charset="-120"/>
+              </a:rPr>
+              <a:t>COUNTDOWN 3·2·1 · FRI 14 →</a:t>
+            </a:r>
+            <a:endParaRPr lang="en-US" sz="900" dirty="0"/>
+          </a:p>
+        </p:txBody>
+      </p:sp>
+      <p:sp>
+        <p:nvSpPr>
+          <p:cNvPr id="12" name="Shape 8"/>
+          <p:cNvSpPr/>
+          <p:nvPr/>
+        </p:nvSpPr>
+        <p:spPr>
+          <a:xfrm>
+            <a:off x="8055864" y="1563624"/>
+            <a:ext cx="3685032" cy="2103120"/>
+          </a:xfrm>
+          <a:prstGeom prst="roundRect">
+            <a:avLst>
+              <a:gd name="adj" fmla="val 2609"/>
+            </a:avLst>
+          </a:prstGeom>
+          <a:solidFill>
+            <a:srgbClr val="F8F1EC"/>
+          </a:solidFill>
+          <a:ln/>
+        </p:spPr>
+      </p:sp>
+      <p:pic>
+        <p:nvPicPr>
+          <p:cNvPr id="13" name="Image 2" descr="/tmp/claude-0/-home-user-predictionmarket/cadac25f-7355-5a2e-945b-6583f4b657ab/scratchpad/deck/designs/launch_og_rally_1600x900.png">    </p:cNvPr>
+          <p:cNvPicPr>
+            <a:picLocks noChangeAspect="1"/>
+          </p:cNvPicPr>
+          <p:nvPr/>
+        </p:nvPicPr>
+        <p:blipFill>
+          <a:blip r:embed="rId4"/>
+          <a:stretch>
+            <a:fillRect/>
+          </a:stretch>
+        </p:blipFill>
+        <p:spPr>
+          <a:xfrm>
+            <a:off x="8092440" y="1600200"/>
+            <a:ext cx="3611880" cy="2029968"/>
+          </a:xfrm>
+          <a:prstGeom prst="rect">
+            <a:avLst/>
+          </a:prstGeom>
+        </p:spPr>
+      </p:pic>
+      <p:sp>
+        <p:nvSpPr>
+          <p:cNvPr id="14" name="Text 9"/>
+          <p:cNvSpPr/>
+          <p:nvPr/>
+        </p:nvSpPr>
+        <p:spPr>
+          <a:xfrm>
+            <a:off x="8092440" y="3675888"/>
+            <a:ext cx="3611880" cy="219456"/>
+          </a:xfrm>
+          <a:prstGeom prst="rect">
+            <a:avLst/>
+          </a:prstGeom>
+          <a:noFill/>
+          <a:ln/>
+        </p:spPr>
+        <p:txBody>
+          <a:bodyPr wrap="square" lIns="0" tIns="0" rIns="0" bIns="0" rtlCol="0" anchor="ctr"/>
+          <a:lstStyle/>
+          <a:p>
+            <a:pPr indent="0" marL="0">
+              <a:buNone/>
+            </a:pPr>
+            <a:r>
+              <a:rPr lang="en-US" sz="900" b="1" dirty="0">
+                <a:solidFill>
+                  <a:srgbClr val="6B6273"/>
+                </a:solidFill>
+                <a:latin typeface="Calibri" pitchFamily="34" charset="0"/>
+                <a:ea typeface="Calibri" pitchFamily="34" charset="-122"/>
+                <a:cs typeface="Calibri" pitchFamily="34" charset="-120"/>
+              </a:rPr>
+              <a:t>LAUNCH THREAD OG · MON 17</a:t>
+            </a:r>
+            <a:endParaRPr lang="en-US" sz="900" dirty="0"/>
+          </a:p>
+        </p:txBody>
+      </p:sp>
+      <p:sp>
+        <p:nvSpPr>
+          <p:cNvPr id="15" name="Shape 10"/>
+          <p:cNvSpPr/>
+          <p:nvPr/>
+        </p:nvSpPr>
+        <p:spPr>
+          <a:xfrm>
+            <a:off x="466344" y="4005072"/>
+            <a:ext cx="3685032" cy="2103120"/>
+          </a:xfrm>
+          <a:prstGeom prst="roundRect">
+            <a:avLst>
+              <a:gd name="adj" fmla="val 2609"/>
+            </a:avLst>
+          </a:prstGeom>
+          <a:solidFill>
+            <a:srgbClr val="F8F1EC"/>
+          </a:solidFill>
+          <a:ln/>
+        </p:spPr>
+      </p:sp>
+      <p:pic>
+        <p:nvPicPr>
+          <p:cNvPr id="16" name="Image 3" descr="/tmp/claude-0/-home-user-predictionmarket/cadac25f-7355-5a2e-945b-6583f4b657ab/scratchpad/deck/designs/howitworks_og_rally_1600x900.png">    </p:cNvPr>
+          <p:cNvPicPr>
+            <a:picLocks noChangeAspect="1"/>
+          </p:cNvPicPr>
+          <p:nvPr/>
+        </p:nvPicPr>
+        <p:blipFill>
+          <a:blip r:embed="rId5"/>
+          <a:stretch>
+            <a:fillRect/>
+          </a:stretch>
+        </p:blipFill>
+        <p:spPr>
+          <a:xfrm>
+            <a:off x="502920" y="4041648"/>
+            <a:ext cx="3611880" cy="2029968"/>
+          </a:xfrm>
+          <a:prstGeom prst="rect">
+            <a:avLst/>
+          </a:prstGeom>
+        </p:spPr>
+      </p:pic>
+      <p:sp>
+        <p:nvSpPr>
+          <p:cNvPr id="17" name="Text 11"/>
+          <p:cNvSpPr/>
+          <p:nvPr/>
+        </p:nvSpPr>
+        <p:spPr>
+          <a:xfrm>
+            <a:off x="502920" y="6117336"/>
+            <a:ext cx="3611880" cy="219456"/>
+          </a:xfrm>
+          <a:prstGeom prst="rect">
+            <a:avLst/>
+          </a:prstGeom>
+          <a:noFill/>
+          <a:ln/>
+        </p:spPr>
+        <p:txBody>
+          <a:bodyPr wrap="square" lIns="0" tIns="0" rIns="0" bIns="0" rtlCol="0" anchor="ctr"/>
+          <a:lstStyle/>
+          <a:p>
+            <a:pPr indent="0" marL="0">
+              <a:buNone/>
+            </a:pPr>
+            <a:r>
+              <a:rPr lang="en-US" sz="900" b="1" dirty="0">
+                <a:solidFill>
+                  <a:srgbClr val="6B6273"/>
+                </a:solidFill>
+                <a:latin typeface="Calibri" pitchFamily="34" charset="0"/>
+                <a:ea typeface="Calibri" pitchFamily="34" charset="-122"/>
+                <a:cs typeface="Calibri" pitchFamily="34" charset="-120"/>
+              </a:rPr>
+              <a:t>“HOW IT WORKS” ARTICLE OG · MON 17</a:t>
+            </a:r>
+            <a:endParaRPr lang="en-US" sz="900" dirty="0"/>
+          </a:p>
+        </p:txBody>
+      </p:sp>
+      <p:sp>
+        <p:nvSpPr>
+          <p:cNvPr id="18" name="Shape 12"/>
+          <p:cNvSpPr/>
+          <p:nvPr/>
+        </p:nvSpPr>
+        <p:spPr>
+          <a:xfrm>
+            <a:off x="4261104" y="4005072"/>
+            <a:ext cx="2103120" cy="2103120"/>
+          </a:xfrm>
+          <a:prstGeom prst="roundRect">
+            <a:avLst>
+              <a:gd name="adj" fmla="val 2609"/>
+            </a:avLst>
+          </a:prstGeom>
+          <a:solidFill>
+            <a:srgbClr val="F8F1EC"/>
+          </a:solidFill>
+          <a:ln/>
+        </p:spPr>
+      </p:sp>
+      <p:pic>
+        <p:nvPicPr>
+          <p:cNvPr id="19" name="Image 4" descr="/tmp/claude-0/-home-user-predictionmarket/cadac25f-7355-5a2e-945b-6583f4b657ab/scratchpad/deck/designs/campaigns_are_live_1080x1080.png">    </p:cNvPr>
+          <p:cNvPicPr>
+            <a:picLocks noChangeAspect="1"/>
+          </p:cNvPicPr>
+          <p:nvPr/>
+        </p:nvPicPr>
+        <p:blipFill>
+          <a:blip r:embed="rId6"/>
+          <a:stretch>
+            <a:fillRect/>
+          </a:stretch>
+        </p:blipFill>
+        <p:spPr>
+          <a:xfrm>
+            <a:off x="4297680" y="4041648"/>
+            <a:ext cx="2029968" cy="2029968"/>
+          </a:xfrm>
+          <a:prstGeom prst="rect">
+            <a:avLst/>
+          </a:prstGeom>
+        </p:spPr>
+      </p:pic>
+      <p:sp>
+        <p:nvSpPr>
+          <p:cNvPr id="20" name="Text 13"/>
+          <p:cNvSpPr/>
+          <p:nvPr/>
+        </p:nvSpPr>
+        <p:spPr>
+          <a:xfrm>
+            <a:off x="4297680" y="6117336"/>
+            <a:ext cx="2029968" cy="219456"/>
+          </a:xfrm>
+          <a:prstGeom prst="rect">
+            <a:avLst/>
+          </a:prstGeom>
+          <a:noFill/>
+          <a:ln/>
+        </p:spPr>
+        <p:txBody>
+          <a:bodyPr wrap="square" lIns="0" tIns="0" rIns="0" bIns="0" rtlCol="0" anchor="ctr"/>
+          <a:lstStyle/>
+          <a:p>
+            <a:pPr indent="0" marL="0">
+              <a:buNone/>
+            </a:pPr>
+            <a:r>
+              <a:rPr lang="en-US" sz="900" b="1" dirty="0">
+                <a:solidFill>
+                  <a:srgbClr val="6B6273"/>
+                </a:solidFill>
+                <a:latin typeface="Calibri" pitchFamily="34" charset="0"/>
+                <a:ea typeface="Calibri" pitchFamily="34" charset="-122"/>
+                <a:cs typeface="Calibri" pitchFamily="34" charset="-120"/>
+              </a:rPr>
+              <a:t>LIVE POST · MON 17</a:t>
+            </a:r>
+            <a:endParaRPr lang="en-US" sz="900" dirty="0"/>
+          </a:p>
+        </p:txBody>
+      </p:sp>
+      <p:sp>
+        <p:nvSpPr>
+          <p:cNvPr id="21" name="Shape 14"/>
+          <p:cNvSpPr/>
+          <p:nvPr/>
+        </p:nvSpPr>
+        <p:spPr>
+          <a:xfrm>
+            <a:off x="6473952" y="4169664"/>
+            <a:ext cx="5148072" cy="1764792"/>
+          </a:xfrm>
+          <a:prstGeom prst="roundRect">
+            <a:avLst>
+              <a:gd name="adj" fmla="val 3109"/>
+            </a:avLst>
+          </a:prstGeom>
+          <a:solidFill>
+            <a:srgbClr val="F8F1EC"/>
+          </a:solidFill>
+          <a:ln/>
+        </p:spPr>
+      </p:sp>
+      <p:pic>
+        <p:nvPicPr>
+          <p:cNvPr id="22" name="Image 5" descr="/tmp/claude-0/-home-user-predictionmarket/cadac25f-7355-5a2e-945b-6583f4b657ab/scratchpad/deck/designs/email_header_rally_1200x400.png">    </p:cNvPr>
+          <p:cNvPicPr>
+            <a:picLocks noChangeAspect="1"/>
+          </p:cNvPicPr>
+          <p:nvPr/>
+        </p:nvPicPr>
+        <p:blipFill>
+          <a:blip r:embed="rId7"/>
+          <a:stretch>
+            <a:fillRect/>
+          </a:stretch>
+        </p:blipFill>
+        <p:spPr>
+          <a:xfrm>
+            <a:off x="6510528" y="4206240"/>
+            <a:ext cx="5074920" cy="1691640"/>
+          </a:xfrm>
+          <a:prstGeom prst="rect">
+            <a:avLst/>
+          </a:prstGeom>
+        </p:spPr>
+      </p:pic>
+      <p:sp>
+        <p:nvSpPr>
+          <p:cNvPr id="23" name="Text 15"/>
+          <p:cNvSpPr/>
+          <p:nvPr/>
+        </p:nvSpPr>
+        <p:spPr>
+          <a:xfrm>
+            <a:off x="6510528" y="5943600"/>
+            <a:ext cx="5074920" cy="219456"/>
+          </a:xfrm>
+          <a:prstGeom prst="rect">
+            <a:avLst/>
+          </a:prstGeom>
+          <a:noFill/>
+          <a:ln/>
+        </p:spPr>
+        <p:txBody>
+          <a:bodyPr wrap="square" lIns="0" tIns="0" rIns="0" bIns="0" rtlCol="0" anchor="ctr"/>
+          <a:lstStyle/>
+          <a:p>
+            <a:pPr indent="0" marL="0">
+              <a:buNone/>
+            </a:pPr>
+            <a:r>
+              <a:rPr lang="en-US" sz="900" b="1" dirty="0">
+                <a:solidFill>
+                  <a:srgbClr val="6B6273"/>
+                </a:solidFill>
+                <a:latin typeface="Calibri" pitchFamily="34" charset="0"/>
+                <a:ea typeface="Calibri" pitchFamily="34" charset="-122"/>
+                <a:cs typeface="Calibri" pitchFamily="34" charset="-120"/>
+              </a:rPr>
+              <a:t>EMAIL HEADER · MON 17</a:t>
+            </a:r>
+            <a:endParaRPr lang="en-US" sz="900" dirty="0"/>
+          </a:p>
+        </p:txBody>
+      </p:sp>
+    </p:spTree>
+  </p:cSld>
+  <p:clrMapOvr>
+    <a:masterClrMapping/>
+  </p:clrMapOvr>
+</p:sld>
+</file>
+
+<file path=ppt/slides/slide11.xml><?xml version="1.0" encoding="utf-8"?>
+<p:sld xmlns:a="http://schemas.openxmlformats.org/drawingml/2006/main" xmlns:r="http://schemas.openxmlformats.org/officeDocument/2006/relationships" xmlns:p="http://schemas.openxmlformats.org/presentationml/2006/main">
+  <p:cSld name="Slide 11">
+    <p:spTree>
+      <p:nvGrpSpPr>
+        <p:cNvPr id="1" name=""/>
+        <p:cNvGrpSpPr/>
+        <p:nvPr/>
+      </p:nvGrpSpPr>
+      <p:grpSpPr>
+        <a:xfrm>
+          <a:off x="0" y="0"/>
+          <a:ext cx="0" cy="0"/>
+          <a:chOff x="0" y="0"/>
+          <a:chExt cx="0" cy="0"/>
+        </a:xfrm>
+      </p:grpSpPr>
+      <p:sp>
+        <p:nvSpPr>
+          <p:cNvPr id="2" name="Text 0"/>
+          <p:cNvSpPr/>
+          <p:nvPr/>
+        </p:nvSpPr>
+        <p:spPr>
+          <a:xfrm>
+            <a:off x="502920" y="347472"/>
+            <a:ext cx="8961120" cy="274320"/>
+          </a:xfrm>
+          <a:prstGeom prst="rect">
+            <a:avLst/>
+          </a:prstGeom>
+          <a:noFill/>
+          <a:ln/>
+        </p:spPr>
+        <p:txBody>
+          <a:bodyPr wrap="square" lIns="0" tIns="0" rIns="0" bIns="0" rtlCol="0" anchor="ctr"/>
+          <a:lstStyle/>
+          <a:p>
+            <a:pPr indent="0" marL="0">
+              <a:buNone/>
+            </a:pPr>
+            <a:r>
+              <a:rPr lang="en-US" sz="1150" b="1" spc="300" kern="0" dirty="0">
+                <a:solidFill>
+                  <a:srgbClr val="FF4E00"/>
+                </a:solidFill>
+                <a:latin typeface="Calibri" pitchFamily="34" charset="0"/>
+                <a:ea typeface="Calibri" pitchFamily="34" charset="-122"/>
+                <a:cs typeface="Calibri" pitchFamily="34" charset="-120"/>
+              </a:rPr>
+              <a:t>DESIGN KIT · ALREADY PRODUCED</a:t>
+            </a:r>
+            <a:endParaRPr lang="en-US" sz="1150" dirty="0"/>
+          </a:p>
+        </p:txBody>
+      </p:sp>
+      <p:sp>
+        <p:nvSpPr>
+          <p:cNvPr id="3" name="Text 1"/>
+          <p:cNvSpPr/>
+          <p:nvPr/>
+        </p:nvSpPr>
+        <p:spPr>
+          <a:xfrm>
+            <a:off x="502920" y="621792"/>
+            <a:ext cx="11155680" cy="548640"/>
+          </a:xfrm>
+          <a:prstGeom prst="rect">
+            <a:avLst/>
+          </a:prstGeom>
+          <a:noFill/>
+          <a:ln/>
+        </p:spPr>
+        <p:txBody>
+          <a:bodyPr wrap="square" lIns="0" tIns="0" rIns="0" bIns="0" rtlCol="0" anchor="ctr"/>
+          <a:lstStyle/>
+          <a:p>
+            <a:pPr indent="0" marL="0">
+              <a:buNone/>
+            </a:pPr>
+            <a:r>
+              <a:rPr lang="en-US" sz="2700" b="1" dirty="0">
+                <a:solidFill>
+                  <a:srgbClr val="2A1A38"/>
+                </a:solidFill>
+                <a:latin typeface="Calibri" pitchFamily="34" charset="0"/>
+                <a:ea typeface="Calibri" pitchFamily="34" charset="-122"/>
+                <a:cs typeface="Calibri" pitchFamily="34" charset="-120"/>
+              </a:rPr>
+              <a:t>Sales, Spaces &amp; weekly templates</a:t>
+            </a:r>
+            <a:endParaRPr lang="en-US" sz="2700" dirty="0"/>
+          </a:p>
+        </p:txBody>
+      </p:sp>
+      <p:sp>
+        <p:nvSpPr>
+          <p:cNvPr id="4" name="Shape 2"/>
+          <p:cNvSpPr/>
+          <p:nvPr/>
+        </p:nvSpPr>
+        <p:spPr>
+          <a:xfrm>
+            <a:off x="9646920" y="365760"/>
+            <a:ext cx="2084832" cy="329184"/>
+          </a:xfrm>
+          <a:prstGeom prst="roundRect">
+            <a:avLst>
+              <a:gd name="adj" fmla="val 38889"/>
+            </a:avLst>
+          </a:prstGeom>
+          <a:solidFill>
+            <a:srgbClr val="FF4E00"/>
+          </a:solidFill>
+          <a:ln/>
+        </p:spPr>
+      </p:sp>
+      <p:sp>
+        <p:nvSpPr>
+          <p:cNvPr id="5" name="Text 3">
+            <a:hlinkClick r:id="rId1" tooltip="Design kit"/>
+          </p:cNvPr>
+          <p:cNvSpPr/>
+          <p:nvPr/>
+        </p:nvSpPr>
+        <p:spPr>
+          <a:xfrm>
+            <a:off x="9646920" y="365760"/>
+            <a:ext cx="2084832" cy="329184"/>
+          </a:xfrm>
+          <a:prstGeom prst="rect">
+            <a:avLst/>
+          </a:prstGeom>
+          <a:noFill/>
+          <a:ln/>
+        </p:spPr>
+        <p:txBody>
+          <a:bodyPr wrap="square" lIns="0" tIns="0" rIns="0" bIns="0" rtlCol="0" anchor="ctr"/>
+          <a:lstStyle/>
+          <a:p>
+            <a:pPr algn="ctr" indent="0" marL="0">
+              <a:buNone/>
+            </a:pPr>
+            <a:r>
+              <a:rPr lang="en-US" sz="1050" b="1" u="sng" dirty="0">
+                <a:solidFill>
+                  <a:srgbClr val="25043A"/>
+                </a:solidFill>
+                <a:latin typeface="Calibri" pitchFamily="34" charset="0"/>
+                <a:ea typeface="Calibri" pitchFamily="34" charset="-122"/>
+                <a:cs typeface="Calibri" pitchFamily="34" charset="-120"/>
+                <a:hlinkClick r:id="rId1" invalidUrl="" action="" tgtFrame="" tooltip="Design kit" history="1" highlightClick="0" endSnd="0">
+                  <a:extLst>
+                    <a:ext uri="{A12FA001-AC4F-418D-AE19-62706E023703}">
+                      <ahyp:hlinkClr xmlns:ahyp="http://schemas.microsoft.com/office/drawing/2018/hyperlinkcolor" val="tx"/>
+                    </a:ext>
+                  </a:extLst>
+                </a:hlinkClick>
+              </a:rPr>
+              <a:t>MASTER DOC  ▸</a:t>
+            </a:r>
+            <a:endParaRPr lang="en-US" sz="1050" dirty="0"/>
+          </a:p>
+        </p:txBody>
+      </p:sp>
+      <p:sp>
+        <p:nvSpPr>
+          <p:cNvPr id="6" name="Shape 4"/>
+          <p:cNvSpPr/>
+          <p:nvPr/>
+        </p:nvSpPr>
+        <p:spPr>
+          <a:xfrm>
+            <a:off x="466344" y="1517904"/>
+            <a:ext cx="3456432" cy="4306824"/>
+          </a:xfrm>
+          <a:prstGeom prst="roundRect">
+            <a:avLst>
+              <a:gd name="adj" fmla="val 1587"/>
+            </a:avLst>
+          </a:prstGeom>
+          <a:solidFill>
+            <a:srgbClr val="F8F1EC"/>
+          </a:solidFill>
+          <a:ln/>
+        </p:spPr>
+      </p:sp>
+      <p:pic>
+        <p:nvPicPr>
+          <p:cNvPr id="7" name="Image 0" descr="/tmp/claude-0/-home-user-predictionmarket/cadac25f-7355-5a2e-945b-6583f4b657ab/scratchpad/deck/designs/verified_onepager_1080x1350.png">    </p:cNvPr>
+          <p:cNvPicPr>
+            <a:picLocks noChangeAspect="1"/>
+          </p:cNvPicPr>
+          <p:nvPr/>
+        </p:nvPicPr>
+        <p:blipFill>
+          <a:blip r:embed="rId2"/>
+          <a:stretch>
+            <a:fillRect/>
+          </a:stretch>
+        </p:blipFill>
+        <p:spPr>
+          <a:xfrm>
+            <a:off x="502920" y="1554480"/>
+            <a:ext cx="3383280" cy="4233672"/>
+          </a:xfrm>
+          <a:prstGeom prst="rect">
+            <a:avLst/>
+          </a:prstGeom>
+        </p:spPr>
+      </p:pic>
+      <p:sp>
+        <p:nvSpPr>
+          <p:cNvPr id="8" name="Text 5"/>
+          <p:cNvSpPr/>
+          <p:nvPr/>
+        </p:nvSpPr>
+        <p:spPr>
+          <a:xfrm>
+            <a:off x="502920" y="5833872"/>
+            <a:ext cx="3383280" cy="219456"/>
+          </a:xfrm>
+          <a:prstGeom prst="rect">
+            <a:avLst/>
+          </a:prstGeom>
+          <a:noFill/>
+          <a:ln/>
+        </p:spPr>
+        <p:txBody>
+          <a:bodyPr wrap="square" lIns="0" tIns="0" rIns="0" bIns="0" rtlCol="0" anchor="ctr"/>
+          <a:lstStyle/>
+          <a:p>
+            <a:pPr indent="0" marL="0">
+              <a:buNone/>
+            </a:pPr>
+            <a:r>
+              <a:rPr lang="en-US" sz="900" b="1" dirty="0">
+                <a:solidFill>
+                  <a:srgbClr val="6B6273"/>
+                </a:solidFill>
+                <a:latin typeface="Calibri" pitchFamily="34" charset="0"/>
+                <a:ea typeface="Calibri" pitchFamily="34" charset="-122"/>
+                <a:cs typeface="Calibri" pitchFamily="34" charset="-120"/>
+              </a:rPr>
+              <a:t>VERIFIED ONE-PAGER · TUE 18</a:t>
+            </a:r>
+            <a:endParaRPr lang="en-US" sz="900" dirty="0"/>
+          </a:p>
+        </p:txBody>
+      </p:sp>
+      <p:sp>
+        <p:nvSpPr>
+          <p:cNvPr id="9" name="Shape 6"/>
+          <p:cNvSpPr/>
+          <p:nvPr/>
+        </p:nvSpPr>
+        <p:spPr>
+          <a:xfrm>
+            <a:off x="4123944" y="1517904"/>
+            <a:ext cx="2505456" cy="1444752"/>
+          </a:xfrm>
+          <a:prstGeom prst="roundRect">
+            <a:avLst>
+              <a:gd name="adj" fmla="val 3797"/>
+            </a:avLst>
+          </a:prstGeom>
+          <a:solidFill>
+            <a:srgbClr val="F8F1EC"/>
+          </a:solidFill>
+          <a:ln/>
+        </p:spPr>
+      </p:sp>
+      <p:pic>
+        <p:nvPicPr>
+          <p:cNvPr id="10" name="Image 1" descr="/tmp/claude-0/-home-user-predictionmarket/cadac25f-7355-5a2e-945b-6583f4b657ab/scratchpad/deck/designs/call_for_projects_1600x900.png">    </p:cNvPr>
+          <p:cNvPicPr>
+            <a:picLocks noChangeAspect="1"/>
+          </p:cNvPicPr>
+          <p:nvPr/>
+        </p:nvPicPr>
+        <p:blipFill>
+          <a:blip r:embed="rId3"/>
+          <a:stretch>
+            <a:fillRect/>
+          </a:stretch>
+        </p:blipFill>
+        <p:spPr>
+          <a:xfrm>
+            <a:off x="4160520" y="1554480"/>
+            <a:ext cx="2432304" cy="1371600"/>
+          </a:xfrm>
+          <a:prstGeom prst="rect">
+            <a:avLst/>
+          </a:prstGeom>
+        </p:spPr>
+      </p:pic>
+      <p:sp>
+        <p:nvSpPr>
+          <p:cNvPr id="11" name="Text 7"/>
+          <p:cNvSpPr/>
+          <p:nvPr/>
+        </p:nvSpPr>
+        <p:spPr>
+          <a:xfrm>
+            <a:off x="4160520" y="2971800"/>
+            <a:ext cx="2432304" cy="219456"/>
+          </a:xfrm>
+          <a:prstGeom prst="rect">
+            <a:avLst/>
+          </a:prstGeom>
+          <a:noFill/>
+          <a:ln/>
+        </p:spPr>
+        <p:txBody>
+          <a:bodyPr wrap="square" lIns="0" tIns="0" rIns="0" bIns="0" rtlCol="0" anchor="ctr"/>
+          <a:lstStyle/>
+          <a:p>
+            <a:pPr indent="0" marL="0">
+              <a:buNone/>
+            </a:pPr>
+            <a:r>
+              <a:rPr lang="en-US" sz="900" b="1" dirty="0">
+                <a:solidFill>
+                  <a:srgbClr val="6B6273"/>
+                </a:solidFill>
+                <a:latin typeface="Calibri" pitchFamily="34" charset="0"/>
+                <a:ea typeface="Calibri" pitchFamily="34" charset="-122"/>
+                <a:cs typeface="Calibri" pitchFamily="34" charset="-120"/>
+              </a:rPr>
+              <a:t>CALL FOR PROJECTS · WED 19</a:t>
+            </a:r>
+            <a:endParaRPr lang="en-US" sz="900" dirty="0"/>
+          </a:p>
+        </p:txBody>
+      </p:sp>
+      <p:sp>
+        <p:nvSpPr>
+          <p:cNvPr id="12" name="Shape 8"/>
+          <p:cNvSpPr/>
+          <p:nvPr/>
+        </p:nvSpPr>
+        <p:spPr>
+          <a:xfrm>
+            <a:off x="6702552" y="1517904"/>
+            <a:ext cx="2505456" cy="1444752"/>
+          </a:xfrm>
+          <a:prstGeom prst="roundRect">
+            <a:avLst>
+              <a:gd name="adj" fmla="val 3797"/>
+            </a:avLst>
+          </a:prstGeom>
+          <a:solidFill>
+            <a:srgbClr val="F8F1EC"/>
+          </a:solidFill>
+          <a:ln/>
+        </p:spPr>
+      </p:sp>
+      <p:pic>
+        <p:nvPicPr>
+          <p:cNvPr id="13" name="Image 2" descr="/tmp/claude-0/-home-user-predictionmarket/cadac25f-7355-5a2e-945b-6583f4b657ab/scratchpad/deck/designs/space_livedemo_1600x900.png">    </p:cNvPr>
+          <p:cNvPicPr>
+            <a:picLocks noChangeAspect="1"/>
+          </p:cNvPicPr>
+          <p:nvPr/>
+        </p:nvPicPr>
+        <p:blipFill>
+          <a:blip r:embed="rId4"/>
+          <a:stretch>
+            <a:fillRect/>
+          </a:stretch>
+        </p:blipFill>
+        <p:spPr>
+          <a:xfrm>
+            <a:off x="6739128" y="1554480"/>
+            <a:ext cx="2432304" cy="1371600"/>
+          </a:xfrm>
+          <a:prstGeom prst="rect">
+            <a:avLst/>
+          </a:prstGeom>
+        </p:spPr>
+      </p:pic>
+      <p:sp>
+        <p:nvSpPr>
+          <p:cNvPr id="14" name="Text 9"/>
+          <p:cNvSpPr/>
+          <p:nvPr/>
+        </p:nvSpPr>
+        <p:spPr>
+          <a:xfrm>
+            <a:off x="6739128" y="2971800"/>
+            <a:ext cx="2432304" cy="219456"/>
+          </a:xfrm>
+          <a:prstGeom prst="rect">
+            <a:avLst/>
+          </a:prstGeom>
+          <a:noFill/>
+          <a:ln/>
+        </p:spPr>
+        <p:txBody>
+          <a:bodyPr wrap="square" lIns="0" tIns="0" rIns="0" bIns="0" rtlCol="0" anchor="ctr"/>
+          <a:lstStyle/>
+          <a:p>
+            <a:pPr indent="0" marL="0">
+              <a:buNone/>
+            </a:pPr>
+            <a:r>
+              <a:rPr lang="en-US" sz="900" b="1" dirty="0">
+                <a:solidFill>
+                  <a:srgbClr val="6B6273"/>
+                </a:solidFill>
+                <a:latin typeface="Calibri" pitchFamily="34" charset="0"/>
+                <a:ea typeface="Calibri" pitchFamily="34" charset="-122"/>
+                <a:cs typeface="Calibri" pitchFamily="34" charset="-120"/>
+              </a:rPr>
+              <a:t>SPACE LIVE DEMO · THU 20</a:t>
+            </a:r>
+            <a:endParaRPr lang="en-US" sz="900" dirty="0"/>
+          </a:p>
+        </p:txBody>
+      </p:sp>
+      <p:sp>
+        <p:nvSpPr>
+          <p:cNvPr id="15" name="Shape 10"/>
+          <p:cNvSpPr/>
+          <p:nvPr/>
+        </p:nvSpPr>
+        <p:spPr>
+          <a:xfrm>
+            <a:off x="9281160" y="1517904"/>
+            <a:ext cx="2505456" cy="1444752"/>
+          </a:xfrm>
+          <a:prstGeom prst="roundRect">
+            <a:avLst>
+              <a:gd name="adj" fmla="val 3797"/>
+            </a:avLst>
+          </a:prstGeom>
+          <a:solidFill>
+            <a:srgbClr val="F8F1EC"/>
+          </a:solidFill>
+          <a:ln/>
+        </p:spPr>
+      </p:sp>
+      <p:pic>
+        <p:nvPicPr>
+          <p:cNvPr id="16" name="Image 3" descr="/tmp/claude-0/-home-user-predictionmarket/cadac25f-7355-5a2e-945b-6583f4b657ab/scratchpad/deck/designs/space_ama_1600x900.png">    </p:cNvPr>
+          <p:cNvPicPr>
+            <a:picLocks noChangeAspect="1"/>
+          </p:cNvPicPr>
+          <p:nvPr/>
+        </p:nvPicPr>
+        <p:blipFill>
+          <a:blip r:embed="rId5"/>
+          <a:stretch>
+            <a:fillRect/>
+          </a:stretch>
+        </p:blipFill>
+        <p:spPr>
+          <a:xfrm>
+            <a:off x="9317736" y="1554480"/>
+            <a:ext cx="2432304" cy="1371600"/>
+          </a:xfrm>
+          <a:prstGeom prst="rect">
+            <a:avLst/>
+          </a:prstGeom>
+        </p:spPr>
+      </p:pic>
+      <p:sp>
+        <p:nvSpPr>
+          <p:cNvPr id="17" name="Text 11"/>
+          <p:cNvSpPr/>
+          <p:nvPr/>
+        </p:nvSpPr>
+        <p:spPr>
+          <a:xfrm>
+            <a:off x="9317736" y="2971800"/>
+            <a:ext cx="2432304" cy="219456"/>
+          </a:xfrm>
+          <a:prstGeom prst="rect">
+            <a:avLst/>
+          </a:prstGeom>
+          <a:noFill/>
+          <a:ln/>
+        </p:spPr>
+        <p:txBody>
+          <a:bodyPr wrap="square" lIns="0" tIns="0" rIns="0" bIns="0" rtlCol="0" anchor="ctr"/>
+          <a:lstStyle/>
+          <a:p>
+            <a:pPr indent="0" marL="0">
+              <a:buNone/>
+            </a:pPr>
+            <a:r>
+              <a:rPr lang="en-US" sz="900" b="1" dirty="0">
+                <a:solidFill>
+                  <a:srgbClr val="6B6273"/>
+                </a:solidFill>
+                <a:latin typeface="Calibri" pitchFamily="34" charset="0"/>
+                <a:ea typeface="Calibri" pitchFamily="34" charset="-122"/>
+                <a:cs typeface="Calibri" pitchFamily="34" charset="-120"/>
+              </a:rPr>
+              <a:t>CREATORS &amp; PARTNERS AMA · SAT 22</a:t>
+            </a:r>
+            <a:endParaRPr lang="en-US" sz="900" dirty="0"/>
+          </a:p>
+        </p:txBody>
+      </p:sp>
+      <p:sp>
+        <p:nvSpPr>
+          <p:cNvPr id="18" name="Shape 12"/>
+          <p:cNvSpPr/>
+          <p:nvPr/>
+        </p:nvSpPr>
+        <p:spPr>
+          <a:xfrm>
+            <a:off x="4123944" y="3273552"/>
+            <a:ext cx="2505456" cy="1444752"/>
+          </a:xfrm>
+          <a:prstGeom prst="roundRect">
+            <a:avLst>
+              <a:gd name="adj" fmla="val 3797"/>
+            </a:avLst>
+          </a:prstGeom>
+          <a:solidFill>
+            <a:srgbClr val="F8F1EC"/>
+          </a:solidFill>
+          <a:ln/>
+        </p:spPr>
+      </p:sp>
+      <p:pic>
+        <p:nvPicPr>
+          <p:cNvPr id="19" name="Image 4" descr="/tmp/claude-0/-home-user-predictionmarket/cadac25f-7355-5a2e-945b-6583f4b657ab/scratchpad/deck/designs/spotlight_template_1600x900.png">    </p:cNvPr>
+          <p:cNvPicPr>
+            <a:picLocks noChangeAspect="1"/>
+          </p:cNvPicPr>
+          <p:nvPr/>
+        </p:nvPicPr>
+        <p:blipFill>
+          <a:blip r:embed="rId6"/>
+          <a:stretch>
+            <a:fillRect/>
+          </a:stretch>
+        </p:blipFill>
+        <p:spPr>
+          <a:xfrm>
+            <a:off x="4160520" y="3310128"/>
+            <a:ext cx="2432304" cy="1371600"/>
+          </a:xfrm>
+          <a:prstGeom prst="rect">
+            <a:avLst/>
+          </a:prstGeom>
+        </p:spPr>
+      </p:pic>
+      <p:sp>
+        <p:nvSpPr>
+          <p:cNvPr id="20" name="Text 13"/>
+          <p:cNvSpPr/>
+          <p:nvPr/>
+        </p:nvSpPr>
+        <p:spPr>
+          <a:xfrm>
+            <a:off x="4160520" y="4727448"/>
+            <a:ext cx="2432304" cy="219456"/>
+          </a:xfrm>
+          <a:prstGeom prst="rect">
+            <a:avLst/>
+          </a:prstGeom>
+          <a:noFill/>
+          <a:ln/>
+        </p:spPr>
+        <p:txBody>
+          <a:bodyPr wrap="square" lIns="0" tIns="0" rIns="0" bIns="0" rtlCol="0" anchor="ctr"/>
+          <a:lstStyle/>
+          <a:p>
+            <a:pPr indent="0" marL="0">
+              <a:buNone/>
+            </a:pPr>
+            <a:r>
+              <a:rPr lang="en-US" sz="900" b="1" dirty="0">
+                <a:solidFill>
+                  <a:srgbClr val="6B6273"/>
+                </a:solidFill>
+                <a:latin typeface="Calibri" pitchFamily="34" charset="0"/>
+                <a:ea typeface="Calibri" pitchFamily="34" charset="-122"/>
+                <a:cs typeface="Calibri" pitchFamily="34" charset="-120"/>
+              </a:rPr>
+              <a:t>SPOTLIGHT TEMPLATE · EVERY MON</a:t>
+            </a:r>
+            <a:endParaRPr lang="en-US" sz="900" dirty="0"/>
+          </a:p>
+        </p:txBody>
+      </p:sp>
+      <p:sp>
+        <p:nvSpPr>
+          <p:cNvPr id="21" name="Shape 14"/>
+          <p:cNvSpPr/>
+          <p:nvPr/>
+        </p:nvSpPr>
+        <p:spPr>
+          <a:xfrm>
+            <a:off x="6702552" y="3273552"/>
+            <a:ext cx="2505456" cy="1444752"/>
+          </a:xfrm>
+          <a:prstGeom prst="roundRect">
+            <a:avLst>
+              <a:gd name="adj" fmla="val 3797"/>
+            </a:avLst>
+          </a:prstGeom>
+          <a:solidFill>
+            <a:srgbClr val="F8F1EC"/>
+          </a:solidFill>
+          <a:ln/>
+        </p:spPr>
+      </p:sp>
+      <p:pic>
+        <p:nvPicPr>
+          <p:cNvPr id="22" name="Image 5" descr="/tmp/claude-0/-home-user-predictionmarket/cadac25f-7355-5a2e-945b-6583f4b657ab/scratchpad/deck/designs/casestudy_numbers_template_1600x900.png">    </p:cNvPr>
+          <p:cNvPicPr>
+            <a:picLocks noChangeAspect="1"/>
+          </p:cNvPicPr>
+          <p:nvPr/>
+        </p:nvPicPr>
+        <p:blipFill>
+          <a:blip r:embed="rId7"/>
+          <a:stretch>
+            <a:fillRect/>
+          </a:stretch>
+        </p:blipFill>
+        <p:spPr>
+          <a:xfrm>
+            <a:off x="6739128" y="3310128"/>
+            <a:ext cx="2432304" cy="1371600"/>
+          </a:xfrm>
+          <a:prstGeom prst="rect">
+            <a:avLst/>
+          </a:prstGeom>
+        </p:spPr>
+      </p:pic>
+      <p:sp>
+        <p:nvSpPr>
+          <p:cNvPr id="23" name="Text 15"/>
+          <p:cNvSpPr/>
+          <p:nvPr/>
+        </p:nvSpPr>
+        <p:spPr>
+          <a:xfrm>
+            <a:off x="6739128" y="4727448"/>
+            <a:ext cx="2432304" cy="219456"/>
+          </a:xfrm>
+          <a:prstGeom prst="rect">
+            <a:avLst/>
+          </a:prstGeom>
+          <a:noFill/>
+          <a:ln/>
+        </p:spPr>
+        <p:txBody>
+          <a:bodyPr wrap="square" lIns="0" tIns="0" rIns="0" bIns="0" rtlCol="0" anchor="ctr"/>
+          <a:lstStyle/>
+          <a:p>
+            <a:pPr indent="0" marL="0">
+              <a:buNone/>
+            </a:pPr>
+            <a:r>
+              <a:rPr lang="en-US" sz="900" b="1" dirty="0">
+                <a:solidFill>
+                  <a:srgbClr val="6B6273"/>
+                </a:solidFill>
+                <a:latin typeface="Calibri" pitchFamily="34" charset="0"/>
+                <a:ea typeface="Calibri" pitchFamily="34" charset="-122"/>
+                <a:cs typeface="Calibri" pitchFamily="34" charset="-120"/>
+              </a:rPr>
+              <a:t>CASE STUDY “RECEIPTS” · WED 26</a:t>
+            </a:r>
+            <a:endParaRPr lang="en-US" sz="900" dirty="0"/>
+          </a:p>
+        </p:txBody>
+      </p:sp>
+      <p:sp>
+        <p:nvSpPr>
+          <p:cNvPr id="24" name="Shape 16"/>
+          <p:cNvSpPr/>
+          <p:nvPr/>
+        </p:nvSpPr>
+        <p:spPr>
+          <a:xfrm>
+            <a:off x="9281160" y="3273552"/>
+            <a:ext cx="2505456" cy="1444752"/>
+          </a:xfrm>
+          <a:prstGeom prst="roundRect">
+            <a:avLst>
+              <a:gd name="adj" fmla="val 3797"/>
+            </a:avLst>
+          </a:prstGeom>
+          <a:solidFill>
+            <a:srgbClr val="F8F1EC"/>
+          </a:solidFill>
+          <a:ln/>
+        </p:spPr>
+      </p:sp>
+      <p:pic>
+        <p:nvPicPr>
+          <p:cNvPr id="25" name="Image 6" descr="/tmp/claude-0/-home-user-predictionmarket/cadac25f-7355-5a2e-945b-6583f4b657ab/scratchpad/deck/designs/network_vs_verified_1920x1080.png">    </p:cNvPr>
+          <p:cNvPicPr>
+            <a:picLocks noChangeAspect="1"/>
+          </p:cNvPicPr>
+          <p:nvPr/>
+        </p:nvPicPr>
+        <p:blipFill>
+          <a:blip r:embed="rId8"/>
+          <a:stretch>
+            <a:fillRect/>
+          </a:stretch>
+        </p:blipFill>
+        <p:spPr>
+          <a:xfrm>
+            <a:off x="9317736" y="3310128"/>
+            <a:ext cx="2432304" cy="1371600"/>
+          </a:xfrm>
+          <a:prstGeom prst="rect">
+            <a:avLst/>
+          </a:prstGeom>
+        </p:spPr>
+      </p:pic>
+      <p:sp>
+        <p:nvSpPr>
+          <p:cNvPr id="26" name="Text 17"/>
+          <p:cNvSpPr/>
+          <p:nvPr/>
+        </p:nvSpPr>
+        <p:spPr>
+          <a:xfrm>
+            <a:off x="9317736" y="4727448"/>
+            <a:ext cx="2432304" cy="219456"/>
+          </a:xfrm>
+          <a:prstGeom prst="rect">
+            <a:avLst/>
+          </a:prstGeom>
+          <a:noFill/>
+          <a:ln/>
+        </p:spPr>
+        <p:txBody>
+          <a:bodyPr wrap="square" lIns="0" tIns="0" rIns="0" bIns="0" rtlCol="0" anchor="ctr"/>
+          <a:lstStyle/>
+          <a:p>
+            <a:pPr indent="0" marL="0">
+              <a:buNone/>
+            </a:pPr>
+            <a:r>
+              <a:rPr lang="en-US" sz="900" b="1" dirty="0">
+                <a:solidFill>
+                  <a:srgbClr val="6B6273"/>
+                </a:solidFill>
+                <a:latin typeface="Calibri" pitchFamily="34" charset="0"/>
+                <a:ea typeface="Calibri" pitchFamily="34" charset="-122"/>
+                <a:cs typeface="Calibri" pitchFamily="34" charset="-120"/>
+              </a:rPr>
+              <a:t>NETWORK VS VERIFIED · WED 19</a:t>
+            </a:r>
+            <a:endParaRPr lang="en-US" sz="900" dirty="0"/>
+          </a:p>
+        </p:txBody>
+      </p:sp>
+      <p:sp>
+        <p:nvSpPr>
+          <p:cNvPr id="27" name="Shape 18"/>
+          <p:cNvSpPr/>
+          <p:nvPr/>
+        </p:nvSpPr>
+        <p:spPr>
+          <a:xfrm>
+            <a:off x="4654296" y="5029200"/>
+            <a:ext cx="1444752" cy="1444752"/>
+          </a:xfrm>
+          <a:prstGeom prst="roundRect">
+            <a:avLst>
+              <a:gd name="adj" fmla="val 3797"/>
+            </a:avLst>
+          </a:prstGeom>
+          <a:solidFill>
+            <a:srgbClr val="F8F1EC"/>
+          </a:solidFill>
+          <a:ln/>
+        </p:spPr>
+      </p:sp>
+      <p:pic>
+        <p:nvPicPr>
+          <p:cNvPr id="28" name="Image 7" descr="/tmp/claude-0/-home-user-predictionmarket/cadac25f-7355-5a2e-945b-6583f4b657ab/scratchpad/deck/designs/idea_battle_1080x1080.png">    </p:cNvPr>
+          <p:cNvPicPr>
+            <a:picLocks noChangeAspect="1"/>
+          </p:cNvPicPr>
+          <p:nvPr/>
+        </p:nvPicPr>
+        <p:blipFill>
+          <a:blip r:embed="rId9"/>
+          <a:stretch>
+            <a:fillRect/>
+          </a:stretch>
+        </p:blipFill>
+        <p:spPr>
+          <a:xfrm>
+            <a:off x="4690872" y="5065776"/>
+            <a:ext cx="1371600" cy="1371600"/>
+          </a:xfrm>
+          <a:prstGeom prst="rect">
+            <a:avLst/>
+          </a:prstGeom>
+        </p:spPr>
+      </p:pic>
+      <p:sp>
+        <p:nvSpPr>
+          <p:cNvPr id="29" name="Text 19"/>
+          <p:cNvSpPr/>
+          <p:nvPr/>
+        </p:nvSpPr>
+        <p:spPr>
+          <a:xfrm>
+            <a:off x="4690872" y="6483096"/>
+            <a:ext cx="1371600" cy="219456"/>
+          </a:xfrm>
+          <a:prstGeom prst="rect">
+            <a:avLst/>
+          </a:prstGeom>
+          <a:noFill/>
+          <a:ln/>
+        </p:spPr>
+        <p:txBody>
+          <a:bodyPr wrap="square" lIns="0" tIns="0" rIns="0" bIns="0" rtlCol="0" anchor="ctr"/>
+          <a:lstStyle/>
+          <a:p>
+            <a:pPr indent="0" marL="0">
+              <a:buNone/>
+            </a:pPr>
+            <a:r>
+              <a:rPr lang="en-US" sz="900" b="1" dirty="0">
+                <a:solidFill>
+                  <a:srgbClr val="6B6273"/>
+                </a:solidFill>
+                <a:latin typeface="Calibri" pitchFamily="34" charset="0"/>
+                <a:ea typeface="Calibri" pitchFamily="34" charset="-122"/>
+                <a:cs typeface="Calibri" pitchFamily="34" charset="-120"/>
+              </a:rPr>
+              <a:t>IDEA BATTLE · SAT 29</a:t>
+            </a:r>
+            <a:endParaRPr lang="en-US" sz="900" dirty="0"/>
+          </a:p>
+        </p:txBody>
+      </p:sp>
+      <p:sp>
+        <p:nvSpPr>
+          <p:cNvPr id="30" name="Shape 20"/>
+          <p:cNvSpPr/>
+          <p:nvPr/>
+        </p:nvSpPr>
+        <p:spPr>
+          <a:xfrm>
+            <a:off x="6702552" y="5029200"/>
+            <a:ext cx="2505456" cy="1444752"/>
+          </a:xfrm>
+          <a:prstGeom prst="roundRect">
+            <a:avLst>
+              <a:gd name="adj" fmla="val 3797"/>
+            </a:avLst>
+          </a:prstGeom>
+          <a:solidFill>
+            <a:srgbClr val="F8F1EC"/>
+          </a:solidFill>
+          <a:ln/>
+        </p:spPr>
+      </p:sp>
+      <p:pic>
+        <p:nvPicPr>
+          <p:cNvPr id="31" name="Image 8" descr="/tmp/claude-0/-home-user-predictionmarket/cadac25f-7355-5a2e-945b-6583f4b657ab/scratchpad/deck/designs/why_permissionless_1920x1080.png">    </p:cNvPr>
+          <p:cNvPicPr>
+            <a:picLocks noChangeAspect="1"/>
+          </p:cNvPicPr>
+          <p:nvPr/>
+        </p:nvPicPr>
+        <p:blipFill>
+          <a:blip r:embed="rId10"/>
+          <a:stretch>
+            <a:fillRect/>
+          </a:stretch>
+        </p:blipFill>
+        <p:spPr>
+          <a:xfrm>
+            <a:off x="6739128" y="5065776"/>
+            <a:ext cx="2432304" cy="1371600"/>
+          </a:xfrm>
+          <a:prstGeom prst="rect">
+            <a:avLst/>
+          </a:prstGeom>
+        </p:spPr>
+      </p:pic>
+      <p:sp>
+        <p:nvSpPr>
+          <p:cNvPr id="32" name="Text 21"/>
+          <p:cNvSpPr/>
+          <p:nvPr/>
+        </p:nvSpPr>
+        <p:spPr>
+          <a:xfrm>
+            <a:off x="6739128" y="6483096"/>
+            <a:ext cx="2432304" cy="219456"/>
+          </a:xfrm>
+          <a:prstGeom prst="rect">
+            <a:avLst/>
+          </a:prstGeom>
+          <a:noFill/>
+          <a:ln/>
+        </p:spPr>
+        <p:txBody>
+          <a:bodyPr wrap="square" lIns="0" tIns="0" rIns="0" bIns="0" rtlCol="0" anchor="ctr"/>
+          <a:lstStyle/>
+          <a:p>
+            <a:pPr indent="0" marL="0">
+              <a:buNone/>
+            </a:pPr>
+            <a:r>
+              <a:rPr lang="en-US" sz="900" b="1" dirty="0">
+                <a:solidFill>
+                  <a:srgbClr val="6B6273"/>
+                </a:solidFill>
+                <a:latin typeface="Calibri" pitchFamily="34" charset="0"/>
+                <a:ea typeface="Calibri" pitchFamily="34" charset="-122"/>
+                <a:cs typeface="Calibri" pitchFamily="34" charset="-120"/>
+              </a:rPr>
+              <a:t>WHY PERMISSIONLESS · W1</a:t>
+            </a:r>
+            <a:endParaRPr lang="en-US" sz="900" dirty="0"/>
+          </a:p>
+        </p:txBody>
+      </p:sp>
+      <p:sp>
+        <p:nvSpPr>
+          <p:cNvPr id="33" name="Shape 22"/>
+          <p:cNvSpPr/>
+          <p:nvPr/>
+        </p:nvSpPr>
+        <p:spPr>
+          <a:xfrm>
+            <a:off x="9317736" y="5065776"/>
+            <a:ext cx="2432304" cy="1371600"/>
+          </a:xfrm>
+          <a:prstGeom prst="roundRect">
+            <a:avLst>
+              <a:gd name="adj" fmla="val 4000"/>
+            </a:avLst>
+          </a:prstGeom>
+          <a:solidFill>
+            <a:srgbClr val="25043A"/>
+          </a:solidFill>
+          <a:ln/>
+        </p:spPr>
+      </p:sp>
+      <p:sp>
+        <p:nvSpPr>
+          <p:cNvPr id="34" name="Text 23"/>
+          <p:cNvSpPr/>
+          <p:nvPr/>
+        </p:nvSpPr>
+        <p:spPr>
+          <a:xfrm>
+            <a:off x="9482328" y="5230368"/>
+            <a:ext cx="2103120" cy="1042416"/>
+          </a:xfrm>
+          <a:prstGeom prst="rect">
+            <a:avLst/>
+          </a:prstGeom>
+          <a:noFill/>
+          <a:ln/>
+        </p:spPr>
+        <p:txBody>
+          <a:bodyPr wrap="square" lIns="0" tIns="0" rIns="0" bIns="0" rtlCol="0" anchor="t"/>
+          <a:lstStyle/>
+          <a:p>
+            <a:pPr indent="0" marL="0">
+              <a:lnSpc>
+                <a:spcPts val="1200"/>
+              </a:lnSpc>
+              <a:buNone/>
+            </a:pPr>
+            <a:r>
+              <a:rPr lang="en-US" sz="950" b="1" dirty="0">
+                <a:solidFill>
+                  <a:srgbClr val="FF4E00"/>
+                </a:solidFill>
+                <a:latin typeface="Calibri" pitchFamily="34" charset="0"/>
+                <a:ea typeface="Calibri" pitchFamily="34" charset="-122"/>
+                <a:cs typeface="Calibri" pitchFamily="34" charset="-120"/>
+              </a:rPr>
+              <a:t>STILL WITH DESIGN/EDITOR</a:t>
+            </a:r>
+            <a:endParaRPr lang="en-US" sz="950" dirty="0"/>
+          </a:p>
+          <a:p>
+            <a:pPr indent="0" marL="0">
+              <a:lnSpc>
+                <a:spcPts val="1200"/>
+              </a:lnSpc>
+              <a:buNone/>
+            </a:pPr>
+            <a:r>
+              <a:rPr lang="en-US" sz="950" dirty="0">
+                <a:solidFill>
+                  <a:srgbClr val="E8DCEF"/>
+                </a:solidFill>
+                <a:latin typeface="Calibri" pitchFamily="34" charset="0"/>
+                <a:ea typeface="Calibri" pitchFamily="34" charset="-122"/>
+                <a:cs typeface="Calibri" pitchFamily="34" charset="-120"/>
+              </a:rPr>
+              <a:t>Demo Video edit · cutdowns 15/30s · KOL clips · lower-thirds</a:t>
+            </a:r>
+            <a:endParaRPr lang="en-US" sz="950" dirty="0"/>
+          </a:p>
+        </p:txBody>
+      </p:sp>
+      <p:sp>
+        <p:nvSpPr>
+          <p:cNvPr id="35" name="Text 24"/>
+          <p:cNvSpPr/>
+          <p:nvPr/>
+        </p:nvSpPr>
+        <p:spPr>
+          <a:xfrm>
+            <a:off x="502920" y="6199632"/>
+            <a:ext cx="3977640" cy="548640"/>
+          </a:xfrm>
+          <a:prstGeom prst="rect">
+            <a:avLst/>
+          </a:prstGeom>
+          <a:noFill/>
+          <a:ln/>
+        </p:spPr>
+        <p:txBody>
+          <a:bodyPr wrap="square" lIns="0" tIns="0" rIns="0" bIns="0" rtlCol="0" anchor="ctr"/>
+          <a:lstStyle/>
+          <a:p>
+            <a:pPr indent="0" marL="0">
+              <a:lnSpc>
+                <a:spcPts val="1250"/>
+              </a:lnSpc>
+              <a:buNone/>
+            </a:pPr>
+            <a:r>
+              <a:rPr lang="en-US" sz="1050" i="1" dirty="0">
+                <a:solidFill>
+                  <a:srgbClr val="25043A"/>
+                </a:solidFill>
+                <a:latin typeface="Calibri" pitchFamily="34" charset="0"/>
+                <a:ea typeface="Calibri" pitchFamily="34" charset="-122"/>
+                <a:cs typeface="Calibri" pitchFamily="34" charset="-120"/>
+              </a:rPr>
+              <a:t>17 static assets produced in Rally's graphic line — regenerable in minutes (copy, dates, sizes).</a:t>
+            </a:r>
+            <a:endParaRPr lang="en-US" sz="1050" dirty="0"/>
+          </a:p>
+        </p:txBody>
+      </p:sp>
+    </p:spTree>
+  </p:cSld>
+  <p:clrMapOvr>
+    <a:masterClrMapping/>
+  </p:clrMapOvr>
+</p:sld>
+</file>
+
+<file path=ppt/slides/slide12.xml><?xml version="1.0" encoding="utf-8"?>
+<p:sld xmlns:a="http://schemas.openxmlformats.org/drawingml/2006/main" xmlns:r="http://schemas.openxmlformats.org/officeDocument/2006/relationships" xmlns:p="http://schemas.openxmlformats.org/presentationml/2006/main">
+  <p:cSld name="Slide 12">
+    <p:spTree>
+      <p:nvGrpSpPr>
+        <p:cNvPr id="1" name=""/>
+        <p:cNvGrpSpPr/>
+        <p:nvPr/>
+      </p:nvGrpSpPr>
+      <p:grpSpPr>
+        <a:xfrm>
+          <a:off x="0" y="0"/>
+          <a:ext cx="0" cy="0"/>
+          <a:chOff x="0" y="0"/>
+          <a:chExt cx="0" cy="0"/>
+        </a:xfrm>
+      </p:grpSpPr>
       <p:pic>
         <p:nvPicPr>
           <p:cNvPr id="2" name="Image 0" descr="/tmp/claude-0/-home-user-predictionmarket/cadac25f-7355-5a2e-945b-6583f4b657ab/scratchpad/deck/brand/rally_white.png">    </p:cNvPr>

</xml_diff>

<commit_message>
Shift campaign start to Wednesday Aug 26
Recalculated the full calendar: pre-launch Aug 24-25, launch Aug 26,
launch phase through Sep 1, social-proof phase Sep 2-8. Weekends keep
only Spaces/community events and Spotlight stays on Monday. Updated the
deck (pillars, calendar, design waves, kit labels, closing line) and the
six dated design assets.

Co-Authored-By: Claude Fable 5 <noreply@anthropic.com>
Claude-Session: https://claude.ai/code/session_01HeCjF7fsjCUn5ySBJ1uikn
</commit_message>
<xml_diff>
--- a/marketing/Rally_Permissionless_Campaigns_Plan.pptx
+++ b/marketing/Rally_Permissionless_Campaigns_Plan.pptx
@@ -2014,7 +2014,7 @@
                 <a:ea typeface="Calibri" pitchFamily="34" charset="-122"/>
                 <a:cs typeface="Calibri" pitchFamily="34" charset="-120"/>
               </a:rPr>
-              <a:t>GO-TO-MARKET · AUG 2026</a:t>
+              <a:t>GO-TO-MARKET · AUG–SEP 2026</a:t>
             </a:r>
             <a:endParaRPr lang="en-US" sz="1250" dirty="0"/>
           </a:p>
@@ -2437,7 +2437,7 @@
                 <a:ea typeface="Calibri" pitchFamily="34" charset="-122"/>
                 <a:cs typeface="Calibri" pitchFamily="34" charset="-120"/>
               </a:rPr>
-              <a:t>TEASER · THU 13</a:t>
+              <a:t>TEASER · MON AUG 24</a:t>
             </a:r>
             <a:endParaRPr lang="en-US" sz="900" dirty="0"/>
           </a:p>
@@ -2522,7 +2522,7 @@
                 <a:ea typeface="Calibri" pitchFamily="34" charset="-122"/>
                 <a:cs typeface="Calibri" pitchFamily="34" charset="-120"/>
               </a:rPr>
-              <a:t>COUNTDOWN 3·2·1 · FRI 14 →</a:t>
+              <a:t>COUNTDOWN 3·2·1 · AUG 24–25</a:t>
             </a:r>
             <a:endParaRPr lang="en-US" sz="900" dirty="0"/>
           </a:p>
@@ -2607,7 +2607,7 @@
                 <a:ea typeface="Calibri" pitchFamily="34" charset="-122"/>
                 <a:cs typeface="Calibri" pitchFamily="34" charset="-120"/>
               </a:rPr>
-              <a:t>LAUNCH THREAD OG · MON 17</a:t>
+              <a:t>LAUNCH THREAD OG · WED AUG 26</a:t>
             </a:r>
             <a:endParaRPr lang="en-US" sz="900" dirty="0"/>
           </a:p>
@@ -2692,7 +2692,7 @@
                 <a:ea typeface="Calibri" pitchFamily="34" charset="-122"/>
                 <a:cs typeface="Calibri" pitchFamily="34" charset="-120"/>
               </a:rPr>
-              <a:t>“HOW IT WORKS” ARTICLE OG · MON 17</a:t>
+              <a:t>“HOW IT WORKS” ARTICLE OG · WED AUG 26</a:t>
             </a:r>
             <a:endParaRPr lang="en-US" sz="900" dirty="0"/>
           </a:p>
@@ -2777,7 +2777,7 @@
                 <a:ea typeface="Calibri" pitchFamily="34" charset="-122"/>
                 <a:cs typeface="Calibri" pitchFamily="34" charset="-120"/>
               </a:rPr>
-              <a:t>LIVE POST · MON 17</a:t>
+              <a:t>LIVE POST · WED AUG 26</a:t>
             </a:r>
             <a:endParaRPr lang="en-US" sz="900" dirty="0"/>
           </a:p>
@@ -2862,7 +2862,7 @@
                 <a:ea typeface="Calibri" pitchFamily="34" charset="-122"/>
                 <a:cs typeface="Calibri" pitchFamily="34" charset="-120"/>
               </a:rPr>
-              <a:t>EMAIL HEADER · MON 17</a:t>
+              <a:t>EMAIL HEADER · WED AUG 26</a:t>
             </a:r>
             <a:endParaRPr lang="en-US" sz="900" dirty="0"/>
           </a:p>
@@ -3120,7 +3120,7 @@
                 <a:ea typeface="Calibri" pitchFamily="34" charset="-122"/>
                 <a:cs typeface="Calibri" pitchFamily="34" charset="-120"/>
               </a:rPr>
-              <a:t>VERIFIED ONE-PAGER · TUE 18</a:t>
+              <a:t>VERIFIED ONE-PAGER · THU AUG 27</a:t>
             </a:r>
             <a:endParaRPr lang="en-US" sz="900" dirty="0"/>
           </a:p>
@@ -3205,7 +3205,7 @@
                 <a:ea typeface="Calibri" pitchFamily="34" charset="-122"/>
                 <a:cs typeface="Calibri" pitchFamily="34" charset="-120"/>
               </a:rPr>
-              <a:t>CALL FOR PROJECTS · WED 19</a:t>
+              <a:t>CALL FOR PROJECTS · FRI AUG 28</a:t>
             </a:r>
             <a:endParaRPr lang="en-US" sz="900" dirty="0"/>
           </a:p>
@@ -3290,7 +3290,7 @@
                 <a:ea typeface="Calibri" pitchFamily="34" charset="-122"/>
                 <a:cs typeface="Calibri" pitchFamily="34" charset="-120"/>
               </a:rPr>
-              <a:t>SPACE LIVE DEMO · THU 20</a:t>
+              <a:t>SPACE LIVE DEMO · MON AUG 31</a:t>
             </a:r>
             <a:endParaRPr lang="en-US" sz="900" dirty="0"/>
           </a:p>
@@ -3375,7 +3375,7 @@
                 <a:ea typeface="Calibri" pitchFamily="34" charset="-122"/>
                 <a:cs typeface="Calibri" pitchFamily="34" charset="-120"/>
               </a:rPr>
-              <a:t>CREATORS &amp; PARTNERS AMA · SAT 22</a:t>
+              <a:t>CREATORS &amp; PARTNERS AMA · AUG 29</a:t>
             </a:r>
             <a:endParaRPr lang="en-US" sz="900" dirty="0"/>
           </a:p>
@@ -3545,7 +3545,7 @@
                 <a:ea typeface="Calibri" pitchFamily="34" charset="-122"/>
                 <a:cs typeface="Calibri" pitchFamily="34" charset="-120"/>
               </a:rPr>
-              <a:t>CASE STUDY “RECEIPTS” · WED 26</a:t>
+              <a:t>CASE STUDY “RECEIPTS” · FRI SEP 4</a:t>
             </a:r>
             <a:endParaRPr lang="en-US" sz="900" dirty="0"/>
           </a:p>
@@ -3630,7 +3630,7 @@
                 <a:ea typeface="Calibri" pitchFamily="34" charset="-122"/>
                 <a:cs typeface="Calibri" pitchFamily="34" charset="-120"/>
               </a:rPr>
-              <a:t>NETWORK VS VERIFIED · WED 19</a:t>
+              <a:t>NETWORK VS VERIFIED · FRI AUG 28</a:t>
             </a:r>
             <a:endParaRPr lang="en-US" sz="900" dirty="0"/>
           </a:p>
@@ -3715,7 +3715,7 @@
                 <a:ea typeface="Calibri" pitchFamily="34" charset="-122"/>
                 <a:cs typeface="Calibri" pitchFamily="34" charset="-120"/>
               </a:rPr>
-              <a:t>IDEA BATTLE · SAT 29</a:t>
+              <a:t>IDEA BATTLE · SAT SEP 5</a:t>
             </a:r>
             <a:endParaRPr lang="en-US" sz="900" dirty="0"/>
           </a:p>
@@ -4115,7 +4115,7 @@
                 <a:ea typeface="Calibri" pitchFamily="34" charset="-122"/>
                 <a:cs typeface="Calibri" pitchFamily="34" charset="-120"/>
               </a:rPr>
-              <a:t>Greenlight this week = we ship Monday Aug 17.</a:t>
+              <a:t>Greenlight this week = we ship Wednesday Aug 26.</a:t>
             </a:r>
             <a:endParaRPr lang="en-US" sz="1700" dirty="0"/>
           </a:p>
@@ -7060,7 +7060,7 @@
                 <a:ea typeface="Calibri" pitchFamily="34" charset="-122"/>
                 <a:cs typeface="Calibri" pitchFamily="34" charset="-120"/>
               </a:rPr>
-              <a:t>THU 13</a:t>
+              <a:t>AUG 24</a:t>
             </a:r>
             <a:endParaRPr lang="en-US" sz="950" dirty="0"/>
           </a:p>
@@ -7185,7 +7185,7 @@
                 <a:ea typeface="Calibri" pitchFamily="34" charset="-122"/>
                 <a:cs typeface="Calibri" pitchFamily="34" charset="-120"/>
               </a:rPr>
-              <a:t>FRI 14</a:t>
+              <a:t>AUG 25</a:t>
             </a:r>
             <a:endParaRPr lang="en-US" sz="950" dirty="0"/>
           </a:p>
@@ -7310,7 +7310,7 @@
                 <a:ea typeface="Calibri" pitchFamily="34" charset="-122"/>
                 <a:cs typeface="Calibri" pitchFamily="34" charset="-120"/>
               </a:rPr>
-              <a:t>MON 17</a:t>
+              <a:t>AUG 26</a:t>
             </a:r>
             <a:endParaRPr lang="en-US" sz="950" dirty="0"/>
           </a:p>
@@ -7435,7 +7435,7 @@
                 <a:ea typeface="Calibri" pitchFamily="34" charset="-122"/>
                 <a:cs typeface="Calibri" pitchFamily="34" charset="-120"/>
               </a:rPr>
-              <a:t>MON 17→</a:t>
+              <a:t>AUG 26→</a:t>
             </a:r>
             <a:endParaRPr lang="en-US" sz="950" dirty="0"/>
           </a:p>
@@ -7685,7 +7685,7 @@
                 <a:ea typeface="Calibri" pitchFamily="34" charset="-122"/>
                 <a:cs typeface="Calibri" pitchFamily="34" charset="-120"/>
               </a:rPr>
-              <a:t>FRI 28</a:t>
+              <a:t>SEP 8</a:t>
             </a:r>
             <a:endParaRPr lang="en-US" sz="950" dirty="0"/>
           </a:p>
@@ -8273,7 +8273,7 @@
                 <a:ea typeface="Calibri" pitchFamily="34" charset="-122"/>
                 <a:cs typeface="Calibri" pitchFamily="34" charset="-120"/>
               </a:rPr>
-              <a:t>TUE 18</a:t>
+              <a:t>AUG 27</a:t>
             </a:r>
             <a:endParaRPr lang="en-US" sz="950" dirty="0"/>
           </a:p>
@@ -8398,7 +8398,7 @@
                 <a:ea typeface="Calibri" pitchFamily="34" charset="-122"/>
                 <a:cs typeface="Calibri" pitchFamily="34" charset="-120"/>
               </a:rPr>
-              <a:t>WED 19</a:t>
+              <a:t>AUG 28</a:t>
             </a:r>
             <a:endParaRPr lang="en-US" sz="950" dirty="0"/>
           </a:p>
@@ -8523,7 +8523,7 @@
                 <a:ea typeface="Calibri" pitchFamily="34" charset="-122"/>
                 <a:cs typeface="Calibri" pitchFamily="34" charset="-120"/>
               </a:rPr>
-              <a:t>FRI 21</a:t>
+              <a:t>SEP 1</a:t>
             </a:r>
             <a:endParaRPr lang="en-US" sz="950" dirty="0"/>
           </a:p>
@@ -8773,7 +8773,7 @@
                 <a:ea typeface="Calibri" pitchFamily="34" charset="-122"/>
                 <a:cs typeface="Calibri" pitchFamily="34" charset="-120"/>
               </a:rPr>
-              <a:t>WED 26</a:t>
+              <a:t>SEP 4</a:t>
             </a:r>
             <a:endParaRPr lang="en-US" sz="950" dirty="0"/>
           </a:p>
@@ -8815,7 +8815,7 @@
                 <a:ea typeface="Calibri" pitchFamily="34" charset="-122"/>
                 <a:cs typeface="Calibri" pitchFamily="34" charset="-120"/>
               </a:rPr>
-              <a:t>Case study “10 days after the video” + sales article → pipeline</a:t>
+              <a:t>Case study “the receipts” + sales article → pipeline</a:t>
             </a:r>
             <a:endParaRPr lang="en-US" sz="1200" dirty="0"/>
           </a:p>
@@ -8898,7 +8898,7 @@
                 <a:ea typeface="Calibri" pitchFamily="34" charset="-122"/>
                 <a:cs typeface="Calibri" pitchFamily="34" charset="-120"/>
               </a:rPr>
-              <a:t>THU 27</a:t>
+              <a:t>SEP 3</a:t>
             </a:r>
             <a:endParaRPr lang="en-US" sz="950" dirty="0"/>
           </a:p>
@@ -9486,7 +9486,7 @@
                 <a:ea typeface="Calibri" pitchFamily="34" charset="-122"/>
                 <a:cs typeface="Calibri" pitchFamily="34" charset="-120"/>
               </a:rPr>
-              <a:t>FRI 21</a:t>
+              <a:t>SEP 1</a:t>
             </a:r>
             <a:endParaRPr lang="en-US" sz="950" dirty="0"/>
           </a:p>
@@ -9611,7 +9611,7 @@
                 <a:ea typeface="Calibri" pitchFamily="34" charset="-122"/>
                 <a:cs typeface="Calibri" pitchFamily="34" charset="-120"/>
               </a:rPr>
-              <a:t>MON 24</a:t>
+              <a:t>SEP 7</a:t>
             </a:r>
             <a:endParaRPr lang="en-US" sz="950" dirty="0"/>
           </a:p>
@@ -9736,7 +9736,7 @@
                 <a:ea typeface="Calibri" pitchFamily="34" charset="-122"/>
                 <a:cs typeface="Calibri" pitchFamily="34" charset="-120"/>
               </a:rPr>
-              <a:t>TUE 25</a:t>
+              <a:t>SEP 2</a:t>
             </a:r>
             <a:endParaRPr lang="en-US" sz="950" dirty="0"/>
           </a:p>
@@ -9986,7 +9986,7 @@
                 <a:ea typeface="Calibri" pitchFamily="34" charset="-122"/>
                 <a:cs typeface="Calibri" pitchFamily="34" charset="-120"/>
               </a:rPr>
-              <a:t>SAT 29</a:t>
+              <a:t>SEP 5</a:t>
             </a:r>
             <a:endParaRPr lang="en-US" sz="950" dirty="0"/>
           </a:p>
@@ -10574,7 +10574,7 @@
                 <a:ea typeface="Calibri" pitchFamily="34" charset="-122"/>
                 <a:cs typeface="Calibri" pitchFamily="34" charset="-120"/>
               </a:rPr>
-              <a:t>MON 17</a:t>
+              <a:t>AUG 26</a:t>
             </a:r>
             <a:endParaRPr lang="en-US" sz="950" dirty="0"/>
           </a:p>
@@ -10699,7 +10699,7 @@
                 <a:ea typeface="Calibri" pitchFamily="34" charset="-122"/>
                 <a:cs typeface="Calibri" pitchFamily="34" charset="-120"/>
               </a:rPr>
-              <a:t>WED 19</a:t>
+              <a:t>AUG 28</a:t>
             </a:r>
             <a:endParaRPr lang="en-US" sz="950" dirty="0"/>
           </a:p>
@@ -10824,7 +10824,7 @@
                 <a:ea typeface="Calibri" pitchFamily="34" charset="-122"/>
                 <a:cs typeface="Calibri" pitchFamily="34" charset="-120"/>
               </a:rPr>
-              <a:t>THU 20</a:t>
+              <a:t>AUG 31</a:t>
             </a:r>
             <a:endParaRPr lang="en-US" sz="950" dirty="0"/>
           </a:p>
@@ -10949,7 +10949,7 @@
                 <a:ea typeface="Calibri" pitchFamily="34" charset="-122"/>
                 <a:cs typeface="Calibri" pitchFamily="34" charset="-120"/>
               </a:rPr>
-              <a:t>SAT 22</a:t>
+              <a:t>AUG 29</a:t>
             </a:r>
             <a:endParaRPr lang="en-US" sz="950" dirty="0"/>
           </a:p>
@@ -11612,7 +11612,7 @@
                 <a:ea typeface="Calibri" pitchFamily="34" charset="-122"/>
                 <a:cs typeface="Calibri" pitchFamily="34" charset="-120"/>
               </a:rPr>
-              <a:t>PRE-LAUNCH: Thu 13 teaser · Fri 14 countdown</a:t>
+              <a:t>PRE-LAUNCH: Mon Aug 24 teaser · Tue 25 countdown</a:t>
             </a:r>
             <a:endParaRPr lang="en-US" sz="1050" dirty="0"/>
           </a:p>
@@ -11651,7 +11651,7 @@
                 <a:ea typeface="Calibri" pitchFamily="34" charset="-122"/>
                 <a:cs typeface="Calibri" pitchFamily="34" charset="-120"/>
               </a:rPr>
-              <a:t>WEEK 1 · LAUNCH</a:t>
+              <a:t>LAUNCH · AUG 26 – SEP 1</a:t>
             </a:r>
             <a:endParaRPr lang="en-US" sz="1100" dirty="0"/>
           </a:p>
@@ -11712,7 +11712,7 @@
                 <a:ea typeface="Calibri" pitchFamily="34" charset="-122"/>
                 <a:cs typeface="Calibri" pitchFamily="34" charset="-120"/>
               </a:rPr>
-              <a:t>MON 17</a:t>
+              <a:t>WED 26</a:t>
             </a:r>
             <a:endParaRPr lang="en-US" sz="1050" dirty="0"/>
           </a:p>
@@ -11897,7 +11897,7 @@
                 <a:ea typeface="Calibri" pitchFamily="34" charset="-122"/>
                 <a:cs typeface="Calibri" pitchFamily="34" charset="-120"/>
               </a:rPr>
-              <a:t>TUE 18</a:t>
+              <a:t>THU 27</a:t>
             </a:r>
             <a:endParaRPr lang="en-US" sz="1050" dirty="0"/>
           </a:p>
@@ -12062,7 +12062,7 @@
                 <a:ea typeface="Calibri" pitchFamily="34" charset="-122"/>
                 <a:cs typeface="Calibri" pitchFamily="34" charset="-120"/>
               </a:rPr>
-              <a:t>WED 19</a:t>
+              <a:t>FRI 28</a:t>
             </a:r>
             <a:endParaRPr lang="en-US" sz="1050" dirty="0"/>
           </a:p>
@@ -12247,7 +12247,7 @@
                 <a:ea typeface="Calibri" pitchFamily="34" charset="-122"/>
                 <a:cs typeface="Calibri" pitchFamily="34" charset="-120"/>
               </a:rPr>
-              <a:t>THU 20</a:t>
+              <a:t>SAT 29</a:t>
             </a:r>
             <a:endParaRPr lang="en-US" sz="1050" dirty="0"/>
           </a:p>
@@ -12309,7 +12309,7 @@
                 <a:ea typeface="Calibri" pitchFamily="34" charset="-122"/>
                 <a:cs typeface="Calibri" pitchFamily="34" charset="-120"/>
               </a:rPr>
-              <a:t>Live Demo</a:t>
+              <a:t>Debrief</a:t>
             </a:r>
             <a:endParaRPr lang="en-US" sz="1300" dirty="0"/>
           </a:p>
@@ -12351,7 +12351,7 @@
                 <a:ea typeface="Calibri" pitchFamily="34" charset="-122"/>
                 <a:cs typeface="Calibri" pitchFamily="34" charset="-120"/>
               </a:rPr>
-              <a:t>“10 minutes” live build + brief guide</a:t>
+              <a:t>X Space: creators &amp; partners AMA</a:t>
             </a:r>
             <a:endParaRPr lang="en-US" sz="900" dirty="0"/>
           </a:p>
@@ -12412,7 +12412,7 @@
                 <a:ea typeface="Calibri" pitchFamily="34" charset="-122"/>
                 <a:cs typeface="Calibri" pitchFamily="34" charset="-120"/>
               </a:rPr>
-              <a:t>FRI 21</a:t>
+              <a:t>MON 31</a:t>
             </a:r>
             <a:endParaRPr lang="en-US" sz="1050" dirty="0"/>
           </a:p>
@@ -12433,34 +12433,14 @@
             <a:avLst/>
           </a:prstGeom>
           <a:solidFill>
-            <a:srgbClr val="C43C00"/>
+            <a:srgbClr val="6E5588"/>
           </a:solidFill>
           <a:ln/>
         </p:spPr>
       </p:sp>
       <p:sp>
         <p:nvSpPr>
-          <p:cNvPr id="41" name="Shape 39"/>
-          <p:cNvSpPr/>
-          <p:nvPr/>
-        </p:nvSpPr>
-        <p:spPr>
-          <a:xfrm>
-            <a:off x="9116568" y="2075688"/>
-            <a:ext cx="137160" cy="137160"/>
-          </a:xfrm>
-          <a:prstGeom prst="ellipse">
-            <a:avLst/>
-          </a:prstGeom>
-          <a:solidFill>
-            <a:srgbClr val="25043A"/>
-          </a:solidFill>
-          <a:ln/>
-        </p:spPr>
-      </p:sp>
-      <p:sp>
-        <p:nvSpPr>
-          <p:cNvPr id="42" name="Text 40"/>
+          <p:cNvPr id="41" name="Text 39"/>
           <p:cNvSpPr/>
           <p:nvPr/>
         </p:nvSpPr>
@@ -12494,7 +12474,7 @@
                 <a:ea typeface="Calibri" pitchFamily="34" charset="-122"/>
                 <a:cs typeface="Calibri" pitchFamily="34" charset="-120"/>
               </a:rPr>
-              <a:t>Creator Video #1</a:t>
+              <a:t>Live Demo</a:t>
             </a:r>
             <a:endParaRPr lang="en-US" sz="1300" dirty="0"/>
           </a:p>
@@ -12502,7 +12482,7 @@
       </p:sp>
       <p:sp>
         <p:nvSpPr>
-          <p:cNvPr id="43" name="Text 41"/>
+          <p:cNvPr id="42" name="Text 40"/>
           <p:cNvSpPr/>
           <p:nvPr/>
         </p:nvSpPr>
@@ -12536,7 +12516,7 @@
                 <a:ea typeface="Calibri" pitchFamily="34" charset="-122"/>
                 <a:cs typeface="Calibri" pitchFamily="34" charset="-120"/>
               </a:rPr>
-              <a:t>testimonial + flagship co-created campaign live</a:t>
+              <a:t>“10 minutes” live build + brief guide</a:t>
             </a:r>
             <a:endParaRPr lang="en-US" sz="900" dirty="0"/>
           </a:p>
@@ -12544,7 +12524,7 @@
       </p:sp>
       <p:sp>
         <p:nvSpPr>
-          <p:cNvPr id="44" name="Shape 42"/>
+          <p:cNvPr id="43" name="Shape 41"/>
           <p:cNvSpPr/>
           <p:nvPr/>
         </p:nvSpPr>
@@ -12566,7 +12546,7 @@
       </p:sp>
       <p:sp>
         <p:nvSpPr>
-          <p:cNvPr id="45" name="Text 43"/>
+          <p:cNvPr id="44" name="Text 42"/>
           <p:cNvSpPr/>
           <p:nvPr/>
         </p:nvSpPr>
@@ -12597,7 +12577,7 @@
                 <a:ea typeface="Calibri" pitchFamily="34" charset="-122"/>
                 <a:cs typeface="Calibri" pitchFamily="34" charset="-120"/>
               </a:rPr>
-              <a:t>SAT 22</a:t>
+              <a:t>TUE 1</a:t>
             </a:r>
             <a:endParaRPr lang="en-US" sz="1050" dirty="0"/>
           </a:p>
@@ -12605,7 +12585,7 @@
       </p:sp>
       <p:sp>
         <p:nvSpPr>
-          <p:cNvPr id="46" name="Shape 44"/>
+          <p:cNvPr id="45" name="Shape 43"/>
           <p:cNvSpPr/>
           <p:nvPr/>
         </p:nvSpPr>
@@ -12618,7 +12598,27 @@
             <a:avLst/>
           </a:prstGeom>
           <a:solidFill>
-            <a:srgbClr val="6E5588"/>
+            <a:srgbClr val="C43C00"/>
+          </a:solidFill>
+          <a:ln/>
+        </p:spPr>
+      </p:sp>
+      <p:sp>
+        <p:nvSpPr>
+          <p:cNvPr id="46" name="Shape 44"/>
+          <p:cNvSpPr/>
+          <p:nvPr/>
+        </p:nvSpPr>
+        <p:spPr>
+          <a:xfrm>
+            <a:off x="11000232" y="2075688"/>
+            <a:ext cx="137160" cy="137160"/>
+          </a:xfrm>
+          <a:prstGeom prst="ellipse">
+            <a:avLst/>
+          </a:prstGeom>
+          <a:solidFill>
+            <a:srgbClr val="25043A"/>
           </a:solidFill>
           <a:ln/>
         </p:spPr>
@@ -12659,7 +12659,7 @@
                 <a:ea typeface="Calibri" pitchFamily="34" charset="-122"/>
                 <a:cs typeface="Calibri" pitchFamily="34" charset="-120"/>
               </a:rPr>
-              <a:t>Debrief</a:t>
+              <a:t>Creator Video #1</a:t>
             </a:r>
             <a:endParaRPr lang="en-US" sz="1300" dirty="0"/>
           </a:p>
@@ -12701,7 +12701,7 @@
                 <a:ea typeface="Calibri" pitchFamily="34" charset="-122"/>
                 <a:cs typeface="Calibri" pitchFamily="34" charset="-120"/>
               </a:rPr>
-              <a:t>X Space: creators &amp; partners AMA</a:t>
+              <a:t>testimonial + flagship co-created campaign live</a:t>
             </a:r>
             <a:endParaRPr lang="en-US" sz="900" dirty="0"/>
           </a:p>
@@ -12740,7 +12740,7 @@
                 <a:ea typeface="Calibri" pitchFamily="34" charset="-122"/>
                 <a:cs typeface="Calibri" pitchFamily="34" charset="-120"/>
               </a:rPr>
-              <a:t>WEEK 2 · SOCIAL PROOF</a:t>
+              <a:t>SOCIAL PROOF · SEP 2 – 8</a:t>
             </a:r>
             <a:endParaRPr lang="en-US" sz="1100" dirty="0"/>
           </a:p>
@@ -12801,7 +12801,7 @@
                 <a:ea typeface="Calibri" pitchFamily="34" charset="-122"/>
                 <a:cs typeface="Calibri" pitchFamily="34" charset="-120"/>
               </a:rPr>
-              <a:t>MON 24</a:t>
+              <a:t>WED 2</a:t>
             </a:r>
             <a:endParaRPr lang="en-US" sz="1050" dirty="0"/>
           </a:p>
@@ -12863,7 +12863,7 @@
                 <a:ea typeface="Calibri" pitchFamily="34" charset="-122"/>
                 <a:cs typeface="Calibri" pitchFamily="34" charset="-120"/>
               </a:rPr>
-              <a:t>Spotlight</a:t>
+              <a:t>Partner Video #2</a:t>
             </a:r>
             <a:endParaRPr lang="en-US" sz="1300" dirty="0"/>
           </a:p>
@@ -12905,7 +12905,7 @@
                 <a:ea typeface="Calibri" pitchFamily="34" charset="-122"/>
                 <a:cs typeface="Calibri" pitchFamily="34" charset="-120"/>
               </a:rPr>
-              <a:t>best community campaigns (every Monday)</a:t>
+              <a:t>community-lead testimonial</a:t>
             </a:r>
             <a:endParaRPr lang="en-US" sz="900" dirty="0"/>
           </a:p>
@@ -12966,7 +12966,7 @@
                 <a:ea typeface="Calibri" pitchFamily="34" charset="-122"/>
                 <a:cs typeface="Calibri" pitchFamily="34" charset="-120"/>
               </a:rPr>
-              <a:t>TUE 25</a:t>
+              <a:t>THU 3</a:t>
             </a:r>
             <a:endParaRPr lang="en-US" sz="1050" dirty="0"/>
           </a:p>
@@ -12987,7 +12987,7 @@
             <a:avLst/>
           </a:prstGeom>
           <a:solidFill>
-            <a:srgbClr val="C43C00"/>
+            <a:srgbClr val="25043A"/>
           </a:solidFill>
           <a:ln/>
         </p:spPr>
@@ -13028,7 +13028,7 @@
                 <a:ea typeface="Calibri" pitchFamily="34" charset="-122"/>
                 <a:cs typeface="Calibri" pitchFamily="34" charset="-120"/>
               </a:rPr>
-              <a:t>Partner Video #2</a:t>
+              <a:t>Vision</a:t>
             </a:r>
             <a:endParaRPr lang="en-US" sz="1300" dirty="0"/>
           </a:p>
@@ -13070,7 +13070,7 @@
                 <a:ea typeface="Calibri" pitchFamily="34" charset="-122"/>
                 <a:cs typeface="Calibri" pitchFamily="34" charset="-120"/>
               </a:rPr>
-              <a:t>community-lead testimonial</a:t>
+              <a:t>“Rally, the Hub of Communities”</a:t>
             </a:r>
             <a:endParaRPr lang="en-US" sz="900" dirty="0"/>
           </a:p>
@@ -13131,7 +13131,7 @@
                 <a:ea typeface="Calibri" pitchFamily="34" charset="-122"/>
                 <a:cs typeface="Calibri" pitchFamily="34" charset="-120"/>
               </a:rPr>
-              <a:t>WED 26</a:t>
+              <a:t>FRI 4</a:t>
             </a:r>
             <a:endParaRPr lang="en-US" sz="1050" dirty="0"/>
           </a:p>
@@ -13235,7 +13235,7 @@
                 <a:ea typeface="Calibri" pitchFamily="34" charset="-122"/>
                 <a:cs typeface="Calibri" pitchFamily="34" charset="-120"/>
               </a:rPr>
-              <a:t>“10 days after” + sales article → pipeline + KOL push</a:t>
+              <a:t>“the receipts” + sales article → pipeline + KOL push</a:t>
             </a:r>
             <a:endParaRPr lang="en-US" sz="900" dirty="0"/>
           </a:p>
@@ -13296,7 +13296,7 @@
                 <a:ea typeface="Calibri" pitchFamily="34" charset="-122"/>
                 <a:cs typeface="Calibri" pitchFamily="34" charset="-120"/>
               </a:rPr>
-              <a:t>THU 27</a:t>
+              <a:t>SAT 5</a:t>
             </a:r>
             <a:endParaRPr lang="en-US" sz="1050" dirty="0"/>
           </a:p>
@@ -13317,7 +13317,7 @@
             <a:avLst/>
           </a:prstGeom>
           <a:solidFill>
-            <a:srgbClr val="25043A"/>
+            <a:srgbClr val="C43C00"/>
           </a:solidFill>
           <a:ln/>
         </p:spPr>
@@ -13358,7 +13358,7 @@
                 <a:ea typeface="Calibri" pitchFamily="34" charset="-122"/>
                 <a:cs typeface="Calibri" pitchFamily="34" charset="-120"/>
               </a:rPr>
-              <a:t>Vision</a:t>
+              <a:t>Community Day</a:t>
             </a:r>
             <a:endParaRPr lang="en-US" sz="1300" dirty="0"/>
           </a:p>
@@ -13400,7 +13400,7 @@
                 <a:ea typeface="Calibri" pitchFamily="34" charset="-122"/>
                 <a:cs typeface="Calibri" pitchFamily="34" charset="-120"/>
               </a:rPr>
-              <a:t>“Rally, the Hub of Communities”</a:t>
+              <a:t>AMA + Campaign Idea Battle (winner funded)</a:t>
             </a:r>
             <a:endParaRPr lang="en-US" sz="900" dirty="0"/>
           </a:p>
@@ -13461,7 +13461,7 @@
                 <a:ea typeface="Calibri" pitchFamily="34" charset="-122"/>
                 <a:cs typeface="Calibri" pitchFamily="34" charset="-120"/>
               </a:rPr>
-              <a:t>FRI 28</a:t>
+              <a:t>MON 7</a:t>
             </a:r>
             <a:endParaRPr lang="en-US" sz="1050" dirty="0"/>
           </a:p>
@@ -13482,7 +13482,7 @@
             <a:avLst/>
           </a:prstGeom>
           <a:solidFill>
-            <a:srgbClr val="FF4E00"/>
+            <a:srgbClr val="C43C00"/>
           </a:solidFill>
           <a:ln/>
         </p:spPr>
@@ -13523,7 +13523,7 @@
                 <a:ea typeface="Calibri" pitchFamily="34" charset="-122"/>
                 <a:cs typeface="Calibri" pitchFamily="34" charset="-120"/>
               </a:rPr>
-              <a:t>Anatomy</a:t>
+              <a:t>Spotlight</a:t>
             </a:r>
             <a:endParaRPr lang="en-US" sz="1300" dirty="0"/>
           </a:p>
@@ -13565,7 +13565,7 @@
                 <a:ea typeface="Calibri" pitchFamily="34" charset="-122"/>
                 <a:cs typeface="Calibri" pitchFamily="34" charset="-120"/>
               </a:rPr>
-              <a:t>receipts thread (screenshots) + cutdown</a:t>
+              <a:t>best community campaigns (every Monday)</a:t>
             </a:r>
             <a:endParaRPr lang="en-US" sz="900" dirty="0"/>
           </a:p>
@@ -13626,7 +13626,7 @@
                 <a:ea typeface="Calibri" pitchFamily="34" charset="-122"/>
                 <a:cs typeface="Calibri" pitchFamily="34" charset="-120"/>
               </a:rPr>
-              <a:t>SAT 29</a:t>
+              <a:t>TUE 8</a:t>
             </a:r>
             <a:endParaRPr lang="en-US" sz="1050" dirty="0"/>
           </a:p>
@@ -13647,7 +13647,7 @@
             <a:avLst/>
           </a:prstGeom>
           <a:solidFill>
-            <a:srgbClr val="C43C00"/>
+            <a:srgbClr val="FF4E00"/>
           </a:solidFill>
           <a:ln/>
         </p:spPr>
@@ -13688,7 +13688,7 @@
                 <a:ea typeface="Calibri" pitchFamily="34" charset="-122"/>
                 <a:cs typeface="Calibri" pitchFamily="34" charset="-120"/>
               </a:rPr>
-              <a:t>Community Day</a:t>
+              <a:t>Anatomy</a:t>
             </a:r>
             <a:endParaRPr lang="en-US" sz="1300" dirty="0"/>
           </a:p>
@@ -13730,7 +13730,7 @@
                 <a:ea typeface="Calibri" pitchFamily="34" charset="-122"/>
                 <a:cs typeface="Calibri" pitchFamily="34" charset="-120"/>
               </a:rPr>
-              <a:t>AMA + Campaign Idea Battle (winner funded)</a:t>
+              <a:t>receipts thread (screenshots) + cutdown</a:t>
             </a:r>
             <a:endParaRPr lang="en-US" sz="900" dirty="0"/>
           </a:p>
@@ -14003,7 +14003,7 @@
                 <a:ea typeface="Calibri" pitchFamily="34" charset="-122"/>
                 <a:cs typeface="Calibri" pitchFamily="34" charset="-120"/>
               </a:rPr>
-              <a:t>due Aug 12–14</a:t>
+              <a:t>due Aug 21–25</a:t>
             </a:r>
             <a:endParaRPr lang="en-US" sz="1050" dirty="0"/>
           </a:p>
@@ -14221,7 +14221,7 @@
                 <a:ea typeface="Calibri" pitchFamily="34" charset="-122"/>
                 <a:cs typeface="Calibri" pitchFamily="34" charset="-120"/>
               </a:rPr>
-              <a:t>due Aug 17–21</a:t>
+              <a:t>due Aug 26–31</a:t>
             </a:r>
             <a:endParaRPr lang="en-US" sz="1050" dirty="0"/>
           </a:p>
@@ -14439,7 +14439,7 @@
                 <a:ea typeface="Calibri" pitchFamily="34" charset="-122"/>
                 <a:cs typeface="Calibri" pitchFamily="34" charset="-120"/>
               </a:rPr>
-              <a:t>due Aug 24–26</a:t>
+              <a:t>due Sep 1–3</a:t>
             </a:r>
             <a:endParaRPr lang="en-US" sz="1050" dirty="0"/>
           </a:p>

</xml_diff>